<commit_message>
Refresh NBU delivery documents and presentation
</commit_message>
<xml_diff>
--- a/entregables/Presentacion-NBU.pptx
+++ b/entregables/Presentacion-NBU.pptx
@@ -2,20 +2,20 @@
 <file path=ppt/presentation.xml><?xml version="1.0" encoding="utf-8"?>
 <p:presentation xmlns:p="http://schemas.openxmlformats.org/presentationml/2006/main">
   <p:sldMasterIdLst>
-    <p:sldMasterId xmlns:r="http://schemas.openxmlformats.org/officeDocument/2006/relationships" id="2147483648" r:id="R484767db30d44cab"/>
+    <p:sldMasterId xmlns:r="http://schemas.openxmlformats.org/officeDocument/2006/relationships" id="2147483648" r:id="R68a8d73e3e10474f"/>
   </p:sldMasterIdLst>
   <p:notesMasterIdLst>
-    <p:notesMasterId xmlns:r="http://schemas.openxmlformats.org/officeDocument/2006/relationships" r:id="Rcca1b5c7b6e54125"/>
+    <p:notesMasterId xmlns:r="http://schemas.openxmlformats.org/officeDocument/2006/relationships" r:id="R1296260048054a93"/>
   </p:notesMasterIdLst>
   <p:sldIdLst>
-    <p:sldId xmlns:r="http://schemas.openxmlformats.org/officeDocument/2006/relationships" id="256" r:id="R3666949bc4e240dc"/>
-    <p:sldId xmlns:r="http://schemas.openxmlformats.org/officeDocument/2006/relationships" id="257" r:id="R4be75cd6601147fb"/>
-    <p:sldId xmlns:r="http://schemas.openxmlformats.org/officeDocument/2006/relationships" id="258" r:id="R898db47ab68f478c"/>
-    <p:sldId xmlns:r="http://schemas.openxmlformats.org/officeDocument/2006/relationships" id="259" r:id="R2863dfe1dbac4433"/>
-    <p:sldId xmlns:r="http://schemas.openxmlformats.org/officeDocument/2006/relationships" id="260" r:id="R467670c56a504f9f"/>
-    <p:sldId xmlns:r="http://schemas.openxmlformats.org/officeDocument/2006/relationships" id="261" r:id="R2122863b0b0c409b"/>
-    <p:sldId xmlns:r="http://schemas.openxmlformats.org/officeDocument/2006/relationships" id="262" r:id="R859435e79bdd4fe5"/>
-    <p:sldId xmlns:r="http://schemas.openxmlformats.org/officeDocument/2006/relationships" id="263" r:id="R60118a18f65a4c79"/>
+    <p:sldId xmlns:r="http://schemas.openxmlformats.org/officeDocument/2006/relationships" id="256" r:id="R71070ee779ce4a83"/>
+    <p:sldId xmlns:r="http://schemas.openxmlformats.org/officeDocument/2006/relationships" id="257" r:id="Ra6d3423173c34aa5"/>
+    <p:sldId xmlns:r="http://schemas.openxmlformats.org/officeDocument/2006/relationships" id="258" r:id="R1003b14b45da4644"/>
+    <p:sldId xmlns:r="http://schemas.openxmlformats.org/officeDocument/2006/relationships" id="259" r:id="R0d3a882aa91b4e1e"/>
+    <p:sldId xmlns:r="http://schemas.openxmlformats.org/officeDocument/2006/relationships" id="260" r:id="R8a8cdda21e364a55"/>
+    <p:sldId xmlns:r="http://schemas.openxmlformats.org/officeDocument/2006/relationships" id="261" r:id="Rf0b5d6df71a14436"/>
+    <p:sldId xmlns:r="http://schemas.openxmlformats.org/officeDocument/2006/relationships" id="262" r:id="R15c03f813b574693"/>
+    <p:sldId xmlns:r="http://schemas.openxmlformats.org/officeDocument/2006/relationships" id="263" r:id="R95d50576f53c4267"/>
   </p:sldIdLst>
   <p:sldSz cx="12192000" cy="6858000"/>
   <p:notesSz cx="6858000" cy="9144000"/>
@@ -519,7 +519,7 @@
           <a:lstStyle xmlns:a="http://schemas.openxmlformats.org/drawingml/2006/main"/>
           <a:p xmlns:a="http://schemas.openxmlformats.org/drawingml/2006/main">
             <a:r>
-              <a:t>El sistema cubre dos necesidades relacionadas: seguimiento privado para el estudiante y gestión de datos para el personal. La ficha del proyecto fija cuatro módulos principales.</a:t>
+              <a:t>La inscripción comienza en el sitio web desde cualquier computadora o celular con acceso al servidor. La nueva cuenta queda pendiente; el personal decide si la acepta o la rechaza con un motivo.</a:t>
             </a:r>
           </a:p>
         </p:txBody>
@@ -729,7 +729,7 @@
           <a:lstStyle xmlns:a="http://schemas.openxmlformats.org/drawingml/2006/main"/>
           <a:p xmlns:a="http://schemas.openxmlformats.org/drawingml/2006/main">
             <a:r>
-              <a:t>La experiencia de estudiante prioriza pantallas sencillas que funcionan en navegador móvil. El portal consulta la cuenta autenticada para mostrar las solicitudes, pagos y notificaciones asociadas a ella.</a:t>
+              <a:t>El portal del estudiante funciona en un navegador móvil. Cada persona consulta solo sus solicitudes, depósitos registrados y avisos.</a:t>
             </a:r>
           </a:p>
         </p:txBody>
@@ -799,7 +799,7 @@
           <a:lstStyle xmlns:a="http://schemas.openxmlformats.org/drawingml/2006/main"/>
           <a:p xmlns:a="http://schemas.openxmlformats.org/drawingml/2006/main">
             <a:r>
-              <a:t>Las operaciones de alta, consulta, modificación y eliminación cubren el CRUD solicitado para los módulos administrativos. Las restricciones de relaciones ayudan a evitar borrados que dejen datos vinculados sin referencia.</a:t>
+              <a:t>Los cuatro módulos tienen las operaciones CRUD. Las solicitudes de registro están en una bandeja separada de la lista de estudiantes activos y se aceptan o rechazan con un motivo.</a:t>
             </a:r>
           </a:p>
         </p:txBody>
@@ -986,7 +986,7 @@
           <p:cNvPr id="3" name="Title">
             <a:extLst xmlns:a="http://schemas.openxmlformats.org/drawingml/2006/main">
               <a:ext uri="{FF2B5EF4-FFF2-40B4-BE49-F238E27FC236}">
-                <a16:creationId xmlns:a16="http://schemas.microsoft.com/office/drawing/2014/main" id="{4DA6AE3D-EE6F-4258-B4DA-E72C9DC8E2FA}"/>
+                <a16:creationId xmlns:a16="http://schemas.microsoft.com/office/drawing/2014/main" id="{AD93AF44-A351-46BB-9E11-D78AE32C9C64}"/>
               </a:ext>
             </a:extLst>
           </p:cNvPr>
@@ -1215,7 +1215,7 @@
           <p:cNvPr id="2" name="Subtitle">
             <a:extLst xmlns:a="http://schemas.openxmlformats.org/drawingml/2006/main">
               <a:ext uri="{FF2B5EF4-FFF2-40B4-BE49-F238E27FC236}">
-                <a16:creationId xmlns:a16="http://schemas.microsoft.com/office/drawing/2014/main" id="{62C6C697-3B10-4915-BF56-A9EE277583B8}"/>
+                <a16:creationId xmlns:a16="http://schemas.microsoft.com/office/drawing/2014/main" id="{FF3F9328-4BBC-49DC-BE0F-1CBEF3C252F5}"/>
               </a:ext>
             </a:extLst>
           </p:cNvPr>
@@ -1461,7 +1461,7 @@
           <p:cNvPr id="2" name="Section title">
             <a:extLst xmlns:a="http://schemas.openxmlformats.org/drawingml/2006/main">
               <a:ext uri="{FF2B5EF4-FFF2-40B4-BE49-F238E27FC236}">
-                <a16:creationId xmlns:a16="http://schemas.microsoft.com/office/drawing/2014/main" id="{39DD0C7A-5416-4040-B007-68B21CB3B67E}"/>
+                <a16:creationId xmlns:a16="http://schemas.microsoft.com/office/drawing/2014/main" id="{F4508C61-ADC7-4886-B0A5-9D26C07710D6}"/>
               </a:ext>
             </a:extLst>
           </p:cNvPr>
@@ -1707,7 +1707,7 @@
           <p:cNvPr id="3" name="Title">
             <a:extLst xmlns:a="http://schemas.openxmlformats.org/drawingml/2006/main">
               <a:ext uri="{FF2B5EF4-FFF2-40B4-BE49-F238E27FC236}">
-                <a16:creationId xmlns:a16="http://schemas.microsoft.com/office/drawing/2014/main" id="{B67BEB26-E721-4D5F-8CD0-B650F80BC108}"/>
+                <a16:creationId xmlns:a16="http://schemas.microsoft.com/office/drawing/2014/main" id="{1E88CC1D-EAC8-4E45-94CC-729FAE66E347}"/>
               </a:ext>
             </a:extLst>
           </p:cNvPr>
@@ -1936,7 +1936,7 @@
           <p:cNvPr id="2" name="Body">
             <a:extLst xmlns:a="http://schemas.openxmlformats.org/drawingml/2006/main">
               <a:ext uri="{FF2B5EF4-FFF2-40B4-BE49-F238E27FC236}">
-                <a16:creationId xmlns:a16="http://schemas.microsoft.com/office/drawing/2014/main" id="{98D264EA-784A-4E48-A849-B99984F1A939}"/>
+                <a16:creationId xmlns:a16="http://schemas.microsoft.com/office/drawing/2014/main" id="{1F408659-E23E-49A8-BE3D-C083EA1036F8}"/>
               </a:ext>
             </a:extLst>
           </p:cNvPr>
@@ -2182,7 +2182,7 @@
           <p:cNvPr id="4" name="Title">
             <a:extLst xmlns:a="http://schemas.openxmlformats.org/drawingml/2006/main">
               <a:ext uri="{FF2B5EF4-FFF2-40B4-BE49-F238E27FC236}">
-                <a16:creationId xmlns:a16="http://schemas.microsoft.com/office/drawing/2014/main" id="{47503E09-1EDE-4742-83A2-FD18B1EA1CD4}"/>
+                <a16:creationId xmlns:a16="http://schemas.microsoft.com/office/drawing/2014/main" id="{DF2414D1-C493-4C50-9493-211FD7F387A5}"/>
               </a:ext>
             </a:extLst>
           </p:cNvPr>
@@ -2411,7 +2411,7 @@
           <p:cNvPr id="2" name="Left column">
             <a:extLst xmlns:a="http://schemas.openxmlformats.org/drawingml/2006/main">
               <a:ext uri="{FF2B5EF4-FFF2-40B4-BE49-F238E27FC236}">
-                <a16:creationId xmlns:a16="http://schemas.microsoft.com/office/drawing/2014/main" id="{15287A09-C6E0-4C5E-94B5-BB9007E8CC69}"/>
+                <a16:creationId xmlns:a16="http://schemas.microsoft.com/office/drawing/2014/main" id="{0F045F06-F08E-413A-9D70-11CC786FEFC3}"/>
               </a:ext>
             </a:extLst>
           </p:cNvPr>
@@ -2640,7 +2640,7 @@
           <p:cNvPr id="3" name="Right column">
             <a:extLst xmlns:a="http://schemas.openxmlformats.org/drawingml/2006/main">
               <a:ext uri="{FF2B5EF4-FFF2-40B4-BE49-F238E27FC236}">
-                <a16:creationId xmlns:a16="http://schemas.microsoft.com/office/drawing/2014/main" id="{B84FDF94-9901-4DFF-BCA6-2E12562531CC}"/>
+                <a16:creationId xmlns:a16="http://schemas.microsoft.com/office/drawing/2014/main" id="{766895B9-BD1E-4E5B-8418-FC7D9967D3AD}"/>
               </a:ext>
             </a:extLst>
           </p:cNvPr>
@@ -2886,7 +2886,7 @@
           <p:cNvPr id="3" name="Title">
             <a:extLst xmlns:a="http://schemas.openxmlformats.org/drawingml/2006/main">
               <a:ext uri="{FF2B5EF4-FFF2-40B4-BE49-F238E27FC236}">
-                <a16:creationId xmlns:a16="http://schemas.microsoft.com/office/drawing/2014/main" id="{69A7545D-7154-41C1-8AF5-72515B6A4DD4}"/>
+                <a16:creationId xmlns:a16="http://schemas.microsoft.com/office/drawing/2014/main" id="{0DC59536-6BF0-4C41-902B-CAFB6BF0F7E1}"/>
               </a:ext>
             </a:extLst>
           </p:cNvPr>
@@ -3115,7 +3115,7 @@
           <p:cNvPr id="2" name="Left column">
             <a:extLst xmlns:a="http://schemas.openxmlformats.org/drawingml/2006/main">
               <a:ext uri="{FF2B5EF4-FFF2-40B4-BE49-F238E27FC236}">
-                <a16:creationId xmlns:a16="http://schemas.microsoft.com/office/drawing/2014/main" id="{F97ED679-8260-4394-99FE-901CE4F59C00}"/>
+                <a16:creationId xmlns:a16="http://schemas.microsoft.com/office/drawing/2014/main" id="{686A2825-868F-4CEB-9357-2F08281EC013}"/>
               </a:ext>
             </a:extLst>
           </p:cNvPr>
@@ -3382,12 +3382,12 @@
   </p:cSld>
   <p:clrMap bg1="lt1" tx1="dk1" bg2="lt2" tx2="dk2" accent1="accent1" accent2="accent2" accent3="accent3" accent4="accent4" accent5="accent5" accent6="accent6" hlink="hlink" folHlink="folHlink"/>
   <p:sldLayoutIdLst>
-    <p:sldLayoutId xmlns:r="http://schemas.openxmlformats.org/officeDocument/2006/relationships" id="2147483649" r:id="R8b40fe34f7394b94"/>
-    <p:sldLayoutId xmlns:r="http://schemas.openxmlformats.org/officeDocument/2006/relationships" id="2147483650" r:id="R15079ce2ebd74a53"/>
-    <p:sldLayoutId xmlns:r="http://schemas.openxmlformats.org/officeDocument/2006/relationships" id="2147483651" r:id="R4c88b274f34446e6"/>
-    <p:sldLayoutId xmlns:r="http://schemas.openxmlformats.org/officeDocument/2006/relationships" id="2147483652" r:id="R48fac022d13e484d"/>
-    <p:sldLayoutId xmlns:r="http://schemas.openxmlformats.org/officeDocument/2006/relationships" id="2147483653" r:id="R59e0052fd0944bde"/>
-    <p:sldLayoutId xmlns:r="http://schemas.openxmlformats.org/officeDocument/2006/relationships" id="2147483654" r:id="R71864589ad6b43fa"/>
+    <p:sldLayoutId xmlns:r="http://schemas.openxmlformats.org/officeDocument/2006/relationships" id="2147483649" r:id="R924553cd92b74393"/>
+    <p:sldLayoutId xmlns:r="http://schemas.openxmlformats.org/officeDocument/2006/relationships" id="2147483650" r:id="Rd3c2b0ec04824489"/>
+    <p:sldLayoutId xmlns:r="http://schemas.openxmlformats.org/officeDocument/2006/relationships" id="2147483651" r:id="Rafdac5a60d084bb1"/>
+    <p:sldLayoutId xmlns:r="http://schemas.openxmlformats.org/officeDocument/2006/relationships" id="2147483652" r:id="R57aa81fc0a2c480e"/>
+    <p:sldLayoutId xmlns:r="http://schemas.openxmlformats.org/officeDocument/2006/relationships" id="2147483653" r:id="R3f4ecbabe4a84923"/>
+    <p:sldLayoutId xmlns:r="http://schemas.openxmlformats.org/officeDocument/2006/relationships" id="2147483654" r:id="Rf54ff25aea134cab"/>
   </p:sldLayoutIdLst>
   <p:txStyles>
     <p:titleStyle>
@@ -3935,10 +3935,10 @@
       </p:grpSpPr>
       <p:sp>
         <p:nvSpPr>
-          <p:cNvPr id="6" name="brand-initials">
+          <p:cNvPr id="7" name="brand-initials">
             <a:extLst xmlns:a="http://schemas.openxmlformats.org/drawingml/2006/main">
               <a:ext uri="{FF2B5EF4-FFF2-40B4-BE49-F238E27FC236}">
-                <a16:creationId xmlns:a16="http://schemas.microsoft.com/office/drawing/2014/main" id="{AAC59923-944F-4E2F-9FE4-144C6FA2717A}"/>
+                <a16:creationId xmlns:a16="http://schemas.microsoft.com/office/drawing/2014/main" id="{BBC61A97-020C-47BF-AD99-B611DE174FB6}"/>
               </a:ext>
             </a:extLst>
           </p:cNvPr>
@@ -4097,7 +4097,7 @@
           <p:cNvPr id="2" name="project-name">
             <a:extLst xmlns:a="http://schemas.openxmlformats.org/drawingml/2006/main">
               <a:ext uri="{FF2B5EF4-FFF2-40B4-BE49-F238E27FC236}">
-                <a16:creationId xmlns:a16="http://schemas.microsoft.com/office/drawing/2014/main" id="{7FA8CFF8-9EC2-4B23-8A55-BD32488D1B40}"/>
+                <a16:creationId xmlns:a16="http://schemas.microsoft.com/office/drawing/2014/main" id="{60D58586-D431-48F7-84CA-98156D1DE2EB}"/>
               </a:ext>
             </a:extLst>
           </p:cNvPr>
@@ -4287,7 +4287,7 @@
           <p:cNvPr id="3" name="slogan">
             <a:extLst xmlns:a="http://schemas.openxmlformats.org/drawingml/2006/main">
               <a:ext uri="{FF2B5EF4-FFF2-40B4-BE49-F238E27FC236}">
-                <a16:creationId xmlns:a16="http://schemas.microsoft.com/office/drawing/2014/main" id="{1E0DD10A-B9C5-4C3A-AC99-2F6E3483BA59}"/>
+                <a16:creationId xmlns:a16="http://schemas.microsoft.com/office/drawing/2014/main" id="{B63F6FC2-1A71-4AC0-B66F-E6FA2E6CF2F1}"/>
               </a:ext>
             </a:extLst>
           </p:cNvPr>
@@ -4446,7 +4446,7 @@
           <p:cNvPr id="4" name="program-pair">
             <a:extLst xmlns:a="http://schemas.openxmlformats.org/drawingml/2006/main">
               <a:ext uri="{FF2B5EF4-FFF2-40B4-BE49-F238E27FC236}">
-                <a16:creationId xmlns:a16="http://schemas.microsoft.com/office/drawing/2014/main" id="{BFBB73FC-C0D0-4BFC-93BB-A4EF080FAAAD}"/>
+                <a16:creationId xmlns:a16="http://schemas.microsoft.com/office/drawing/2014/main" id="{5EA5E02E-18AC-48B2-B208-E1D485F17AAA}"/>
               </a:ext>
             </a:extLst>
           </p:cNvPr>
@@ -4605,7 +4605,7 @@
           <p:cNvPr id="5" name="group">
             <a:extLst xmlns:a="http://schemas.openxmlformats.org/drawingml/2006/main">
               <a:ext uri="{FF2B5EF4-FFF2-40B4-BE49-F238E27FC236}">
-                <a16:creationId xmlns:a16="http://schemas.microsoft.com/office/drawing/2014/main" id="{7FA11758-C6B0-4CD8-A72F-5188C7B83EE1}"/>
+                <a16:creationId xmlns:a16="http://schemas.microsoft.com/office/drawing/2014/main" id="{8E3B1703-6CFF-4231-8727-9C4D8744D4F6}"/>
               </a:ext>
             </a:extLst>
           </p:cNvPr>
@@ -4759,10 +4759,38 @@
           </a:p>
         </p:txBody>
       </p:sp>
+      <p:pic>
+        <p:nvPicPr>
+          <p:cNvPr id="6" name="">
+            <a:extLst xmlns:a="http://schemas.openxmlformats.org/drawingml/2006/main">
+              <a:ext uri="{FF2B5EF4-FFF2-40B4-BE49-F238E27FC236}">
+                <a16:creationId xmlns:a16="http://schemas.microsoft.com/office/drawing/2014/main" id="{32823081-348D-41F0-A1D5-4F8DCBC96292}"/>
+              </a:ext>
+            </a:extLst>
+          </p:cNvPr>
+          <p:cNvPicPr>
+            <a:picLocks xmlns:a="http://schemas.openxmlformats.org/drawingml/2006/main" noChangeAspect="1"/>
+          </p:cNvPicPr>
+          <p:nvPr/>
+        </p:nvPicPr>
+        <p:blipFill>
+          <a:blip xmlns:r="http://schemas.openxmlformats.org/officeDocument/2006/relationships" xmlns:a="http://schemas.openxmlformats.org/drawingml/2006/main" r:embed="R5179d5b9bc3d4372"/>
+          <a:stretch xmlns:a="http://schemas.openxmlformats.org/drawingml/2006/main"/>
+        </p:blipFill>
+        <p:spPr>
+          <a:xfrm xmlns:a="http://schemas.openxmlformats.org/drawingml/2006/main">
+            <a:off x="8743950" y="1095375"/>
+            <a:ext cx="2095500" cy="2095500"/>
+          </a:xfrm>
+          <a:prstGeom xmlns:a="http://schemas.openxmlformats.org/drawingml/2006/main" prst="rect">
+            <a:avLst/>
+          </a:prstGeom>
+        </p:spPr>
+      </p:pic>
     </p:spTree>
     <p:extLst>
       <p:ext uri="{BB962C8B-B14F-4D97-AF65-F5344CB8AC3E}">
-        <p14:creationId xmlns:p14="http://schemas.microsoft.com/office/powerpoint/2010/main" val="900829685"/>
+        <p14:creationId xmlns:p14="http://schemas.microsoft.com/office/powerpoint/2010/main" val="1223641928"/>
       </p:ext>
     </p:extLst>
   </p:cSld>
@@ -4788,12 +4816,40 @@
       <p:grpSpPr>
         <a:xfrm xmlns:a="http://schemas.openxmlformats.org/drawingml/2006/main"/>
       </p:grpSpPr>
+      <p:pic>
+        <p:nvPicPr>
+          <p:cNvPr id="10" name="">
+            <a:extLst xmlns:a="http://schemas.openxmlformats.org/drawingml/2006/main">
+              <a:ext uri="{FF2B5EF4-FFF2-40B4-BE49-F238E27FC236}">
+                <a16:creationId xmlns:a16="http://schemas.microsoft.com/office/drawing/2014/main" id="{0ACC10BD-346C-422A-BFD3-C95A49D7BC89}"/>
+              </a:ext>
+            </a:extLst>
+          </p:cNvPr>
+          <p:cNvPicPr>
+            <a:picLocks xmlns:a="http://schemas.openxmlformats.org/drawingml/2006/main" noChangeAspect="1"/>
+          </p:cNvPicPr>
+          <p:nvPr/>
+        </p:nvPicPr>
+        <p:blipFill>
+          <a:blip xmlns:r="http://schemas.openxmlformats.org/officeDocument/2006/relationships" xmlns:a="http://schemas.openxmlformats.org/drawingml/2006/main" r:embed="Rf6dbe3b616294ca2"/>
+          <a:stretch xmlns:a="http://schemas.openxmlformats.org/drawingml/2006/main"/>
+        </p:blipFill>
+        <p:spPr>
+          <a:xfrm xmlns:a="http://schemas.openxmlformats.org/drawingml/2006/main">
+            <a:off x="11096625" y="171450"/>
+            <a:ext cx="381000" cy="381000"/>
+          </a:xfrm>
+          <a:prstGeom xmlns:a="http://schemas.openxmlformats.org/drawingml/2006/main" prst="rect">
+            <a:avLst/>
+          </a:prstGeom>
+        </p:spPr>
+      </p:pic>
       <p:sp>
         <p:nvSpPr>
-          <p:cNvPr id="9" name="footer-2">
+          <p:cNvPr id="2" name="footer-2">
             <a:extLst xmlns:a="http://schemas.openxmlformats.org/drawingml/2006/main">
               <a:ext uri="{FF2B5EF4-FFF2-40B4-BE49-F238E27FC236}">
-                <a16:creationId xmlns:a16="http://schemas.microsoft.com/office/drawing/2014/main" id="{E0CED721-BE77-4A14-9271-D9058DE949E7}"/>
+                <a16:creationId xmlns:a16="http://schemas.microsoft.com/office/drawing/2014/main" id="{DDAE4F01-5430-4966-845A-8D7BADB6AEC5}"/>
               </a:ext>
             </a:extLst>
           </p:cNvPr>
@@ -4949,10 +5005,10 @@
       </p:sp>
       <p:sp>
         <p:nvSpPr>
-          <p:cNvPr id="2" name="slide-title">
+          <p:cNvPr id="3" name="slide-title">
             <a:extLst xmlns:a="http://schemas.openxmlformats.org/drawingml/2006/main">
               <a:ext uri="{FF2B5EF4-FFF2-40B4-BE49-F238E27FC236}">
-                <a16:creationId xmlns:a16="http://schemas.microsoft.com/office/drawing/2014/main" id="{11F9470E-F4D5-4E93-8489-C77278D22255}"/>
+                <a16:creationId xmlns:a16="http://schemas.microsoft.com/office/drawing/2014/main" id="{A64B6C27-8131-476E-981B-9223DC849E58}"/>
               </a:ext>
             </a:extLst>
           </p:cNvPr>
@@ -5101,17 +5157,17 @@
                 <a:ea typeface="Arial"/>
                 <a:cs typeface="Arial"/>
               </a:rPr>
-              <a:t>Una ruta clara para cada beca</a:t>
+              <a:t>Registro desde cualquier lugar</a:t>
             </a:r>
           </a:p>
         </p:txBody>
       </p:sp>
       <p:sp>
         <p:nvSpPr>
-          <p:cNvPr id="3" name="intro">
+          <p:cNvPr id="4" name="intro">
             <a:extLst xmlns:a="http://schemas.openxmlformats.org/drawingml/2006/main">
               <a:ext uri="{FF2B5EF4-FFF2-40B4-BE49-F238E27FC236}">
-                <a16:creationId xmlns:a16="http://schemas.microsoft.com/office/drawing/2014/main" id="{B4F2DCBB-AFD5-402F-8023-AB225795C2A0}"/>
+                <a16:creationId xmlns:a16="http://schemas.microsoft.com/office/drawing/2014/main" id="{994CC1D6-D65F-48C3-BA13-AD4E89F0E9E4}"/>
               </a:ext>
             </a:extLst>
           </p:cNvPr>
@@ -5122,8 +5178,8 @@
         </p:nvSpPr>
         <p:spPr>
           <a:xfrm xmlns:a="http://schemas.openxmlformats.org/drawingml/2006/main">
-            <a:off x="704850" y="1466850"/>
-            <a:ext cx="10334625" cy="781050"/>
+            <a:off x="704850" y="1428750"/>
+            <a:ext cx="10334625" cy="685800"/>
           </a:xfrm>
           <a:prstGeom xmlns:a="http://schemas.openxmlformats.org/drawingml/2006/main" prst="rect">
             <a:avLst/>
@@ -5140,7 +5196,7 @@
           </a:bodyPr>
           <a:lstStyle xmlns:a="http://schemas.openxmlformats.org/drawingml/2006/main">
             <a:defPPr algn="l">
-              <a:defRPr sz="2100">
+              <a:defRPr sz="2025">
                 <a:solidFill>
                   <a:srgbClr val="182B43"/>
                 </a:solidFill>
@@ -5150,7 +5206,7 @@
               </a:defRPr>
             </a:defPPr>
             <a:lvl1pPr algn="l">
-              <a:defRPr sz="2100">
+              <a:defRPr sz="2025">
                 <a:solidFill>
                   <a:srgbClr val="182B43"/>
                 </a:solidFill>
@@ -5160,7 +5216,7 @@
               </a:defRPr>
             </a:lvl1pPr>
             <a:lvl2pPr algn="l">
-              <a:defRPr sz="2100">
+              <a:defRPr sz="2025">
                 <a:solidFill>
                   <a:srgbClr val="182B43"/>
                 </a:solidFill>
@@ -5170,7 +5226,7 @@
               </a:defRPr>
             </a:lvl2pPr>
             <a:lvl3pPr algn="l">
-              <a:defRPr sz="2100">
+              <a:defRPr sz="2025">
                 <a:solidFill>
                   <a:srgbClr val="182B43"/>
                 </a:solidFill>
@@ -5180,7 +5236,7 @@
               </a:defRPr>
             </a:lvl3pPr>
             <a:lvl4pPr algn="l">
-              <a:defRPr sz="2100">
+              <a:defRPr sz="2025">
                 <a:solidFill>
                   <a:srgbClr val="182B43"/>
                 </a:solidFill>
@@ -5190,7 +5246,7 @@
               </a:defRPr>
             </a:lvl4pPr>
             <a:lvl5pPr algn="l">
-              <a:defRPr sz="2100">
+              <a:defRPr sz="2025">
                 <a:solidFill>
                   <a:srgbClr val="182B43"/>
                 </a:solidFill>
@@ -5200,7 +5256,7 @@
               </a:defRPr>
             </a:lvl5pPr>
             <a:lvl6pPr algn="l">
-              <a:defRPr sz="2100">
+              <a:defRPr sz="2025">
                 <a:solidFill>
                   <a:srgbClr val="182B43"/>
                 </a:solidFill>
@@ -5210,7 +5266,7 @@
               </a:defRPr>
             </a:lvl6pPr>
             <a:lvl7pPr algn="l">
-              <a:defRPr sz="2100">
+              <a:defRPr sz="2025">
                 <a:solidFill>
                   <a:srgbClr val="182B43"/>
                 </a:solidFill>
@@ -5220,7 +5276,7 @@
               </a:defRPr>
             </a:lvl7pPr>
             <a:lvl8pPr algn="l">
-              <a:defRPr sz="2100">
+              <a:defRPr sz="2025">
                 <a:solidFill>
                   <a:srgbClr val="182B43"/>
                 </a:solidFill>
@@ -5230,7 +5286,7 @@
               </a:defRPr>
             </a:lvl8pPr>
             <a:lvl9pPr algn="l">
-              <a:defRPr sz="2100">
+              <a:defRPr sz="2025">
                 <a:solidFill>
                   <a:srgbClr val="182B43"/>
                 </a:solidFill>
@@ -5246,7 +5302,7 @@
                 <a:spcPct val="105000"/>
               </a:lnSpc>
               <a:buNone/>
-              <a:defRPr sz="2100">
+              <a:defRPr sz="2025">
                 <a:solidFill>
                   <a:srgbClr val="182B43"/>
                 </a:solidFill>
@@ -5256,7 +5312,7 @@
               </a:defRPr>
             </a:pPr>
             <a:r>
-              <a:rPr sz="2100">
+              <a:rPr sz="2025">
                 <a:solidFill>
                   <a:srgbClr val="182B43"/>
                 </a:solidFill>
@@ -5264,17 +5320,17 @@
                 <a:ea typeface="Arial"/>
                 <a:cs typeface="Arial"/>
               </a:rPr>
-              <a:t>NBU organiza la consulta de oportunidades, el seguimiento de solicitudes y los avisos universitarios en un mismo sistema</a:t>
+              <a:t>Una persona puede crear su cuenta desde la página web. Administración revisa los datos antes de activar el acceso</a:t>
             </a:r>
           </a:p>
         </p:txBody>
       </p:sp>
       <p:sp>
         <p:nvSpPr>
-          <p:cNvPr id="4" name="student-heading">
+          <p:cNvPr id="5" name="student-heading">
             <a:extLst xmlns:a="http://schemas.openxmlformats.org/drawingml/2006/main">
               <a:ext uri="{FF2B5EF4-FFF2-40B4-BE49-F238E27FC236}">
-                <a16:creationId xmlns:a16="http://schemas.microsoft.com/office/drawing/2014/main" id="{FB876136-42FA-4E01-8E6F-64E3CF4B2DBD}"/>
+                <a16:creationId xmlns:a16="http://schemas.microsoft.com/office/drawing/2014/main" id="{EBFC014C-093E-41B5-8E50-117776680D9B}"/>
               </a:ext>
             </a:extLst>
           </p:cNvPr>
@@ -5285,7 +5341,7 @@
         </p:nvSpPr>
         <p:spPr>
           <a:xfrm xmlns:a="http://schemas.openxmlformats.org/drawingml/2006/main">
-            <a:off x="742950" y="2819400"/>
+            <a:off x="742950" y="2590800"/>
             <a:ext cx="4476750" cy="514350"/>
           </a:xfrm>
           <a:prstGeom xmlns:a="http://schemas.openxmlformats.org/drawingml/2006/main" prst="rect">
@@ -5430,10 +5486,10 @@
       </p:sp>
       <p:sp>
         <p:nvSpPr>
-          <p:cNvPr id="5" name="student-copy">
+          <p:cNvPr id="6" name="student-copy">
             <a:extLst xmlns:a="http://schemas.openxmlformats.org/drawingml/2006/main">
               <a:ext uri="{FF2B5EF4-FFF2-40B4-BE49-F238E27FC236}">
-                <a16:creationId xmlns:a16="http://schemas.microsoft.com/office/drawing/2014/main" id="{07CCA07D-EE82-4DC1-BFD3-4CE955EDF0B5}"/>
+                <a16:creationId xmlns:a16="http://schemas.microsoft.com/office/drawing/2014/main" id="{06C76AE0-9387-48FE-9043-32C6E9558000}"/>
               </a:ext>
             </a:extLst>
           </p:cNvPr>
@@ -5444,7 +5500,7 @@
         </p:nvSpPr>
         <p:spPr>
           <a:xfrm xmlns:a="http://schemas.openxmlformats.org/drawingml/2006/main">
-            <a:off x="742950" y="3457575"/>
+            <a:off x="742950" y="3228975"/>
             <a:ext cx="4810125" cy="1619250"/>
           </a:xfrm>
           <a:prstGeom xmlns:a="http://schemas.openxmlformats.org/drawingml/2006/main" prst="rect">
@@ -5586,7 +5642,7 @@
                 <a:ea typeface="Arial"/>
                 <a:cs typeface="Arial"/>
               </a:rPr>
-              <a:t>Consulta convocatorias y requisitos.</a:t>
+              <a:t>Completa sus datos en línea.</a:t>
             </a:r>
           </a:p>
           <a:p xmlns:a="http://schemas.openxmlformats.org/drawingml/2006/main">
@@ -5613,7 +5669,7 @@
                 <a:ea typeface="Arial"/>
                 <a:cs typeface="Arial"/>
               </a:rPr>
-              <a:t>Envía solicitudes y revisa su estado.</a:t>
+              <a:t>Comparte un código de recomendación si desea.</a:t>
             </a:r>
           </a:p>
           <a:p xmlns:a="http://schemas.openxmlformats.org/drawingml/2006/main">
@@ -5640,17 +5696,17 @@
                 <a:ea typeface="Arial"/>
                 <a:cs typeface="Arial"/>
               </a:rPr>
-              <a:t>Ve los depósitos registrados y las noticias.</a:t>
+              <a:t>Espera la revisión antes de iniciar sesión.</a:t>
             </a:r>
           </a:p>
         </p:txBody>
       </p:sp>
       <p:sp>
         <p:nvSpPr>
-          <p:cNvPr id="6" name="staff-heading">
+          <p:cNvPr id="7" name="staff-heading">
             <a:extLst xmlns:a="http://schemas.openxmlformats.org/drawingml/2006/main">
               <a:ext uri="{FF2B5EF4-FFF2-40B4-BE49-F238E27FC236}">
-                <a16:creationId xmlns:a16="http://schemas.microsoft.com/office/drawing/2014/main" id="{3DA40AF5-A2D2-4E67-BD3A-50F03308316B}"/>
+                <a16:creationId xmlns:a16="http://schemas.microsoft.com/office/drawing/2014/main" id="{02E5E442-6363-42C0-82F0-0750971282B7}"/>
               </a:ext>
             </a:extLst>
           </p:cNvPr>
@@ -5661,7 +5717,7 @@
         </p:nvSpPr>
         <p:spPr>
           <a:xfrm xmlns:a="http://schemas.openxmlformats.org/drawingml/2006/main">
-            <a:off x="6286500" y="2819400"/>
+            <a:off x="6286500" y="2590800"/>
             <a:ext cx="4476750" cy="514350"/>
           </a:xfrm>
           <a:prstGeom xmlns:a="http://schemas.openxmlformats.org/drawingml/2006/main" prst="rect">
@@ -5806,10 +5862,10 @@
       </p:sp>
       <p:sp>
         <p:nvSpPr>
-          <p:cNvPr id="7" name="staff-copy">
+          <p:cNvPr id="8" name="staff-copy">
             <a:extLst xmlns:a="http://schemas.openxmlformats.org/drawingml/2006/main">
               <a:ext uri="{FF2B5EF4-FFF2-40B4-BE49-F238E27FC236}">
-                <a16:creationId xmlns:a16="http://schemas.microsoft.com/office/drawing/2014/main" id="{DB81E6A9-3937-4CB6-895D-9522DB61FE19}"/>
+                <a16:creationId xmlns:a16="http://schemas.microsoft.com/office/drawing/2014/main" id="{D5B0766E-A4F4-4D19-98F5-B25C081DAEDC}"/>
               </a:ext>
             </a:extLst>
           </p:cNvPr>
@@ -5820,7 +5876,7 @@
         </p:nvSpPr>
         <p:spPr>
           <a:xfrm xmlns:a="http://schemas.openxmlformats.org/drawingml/2006/main">
-            <a:off x="6286500" y="3457575"/>
+            <a:off x="6286500" y="3228975"/>
             <a:ext cx="5000625" cy="1619250"/>
           </a:xfrm>
           <a:prstGeom xmlns:a="http://schemas.openxmlformats.org/drawingml/2006/main" prst="rect">
@@ -5962,7 +6018,7 @@
                 <a:ea typeface="Arial"/>
                 <a:cs typeface="Arial"/>
               </a:rPr>
-              <a:t>Mantiene estudiantes y becas al día.</a:t>
+              <a:t>Abre Registros pendientes.</a:t>
             </a:r>
           </a:p>
           <a:p xmlns:a="http://schemas.openxmlformats.org/drawingml/2006/main">
@@ -5989,7 +6045,7 @@
                 <a:ea typeface="Arial"/>
                 <a:cs typeface="Arial"/>
               </a:rPr>
-              <a:t>Revisa solicitudes y registra depósitos.</a:t>
+              <a:t>Acepta o rechaza con motivo.</a:t>
             </a:r>
           </a:p>
           <a:p xmlns:a="http://schemas.openxmlformats.org/drawingml/2006/main">
@@ -6016,17 +6072,17 @@
                 <a:ea typeface="Arial"/>
                 <a:cs typeface="Arial"/>
               </a:rPr>
-              <a:t>Publica noticias y avisos.</a:t>
+              <a:t>La persona puede corregir y reenviar.</a:t>
             </a:r>
           </a:p>
         </p:txBody>
       </p:sp>
       <p:sp>
         <p:nvSpPr>
-          <p:cNvPr id="8" name="objective">
+          <p:cNvPr id="9" name="objective">
             <a:extLst xmlns:a="http://schemas.openxmlformats.org/drawingml/2006/main">
               <a:ext uri="{FF2B5EF4-FFF2-40B4-BE49-F238E27FC236}">
-                <a16:creationId xmlns:a16="http://schemas.microsoft.com/office/drawing/2014/main" id="{77740ADE-32A9-48D2-8841-64AC951206B8}"/>
+                <a16:creationId xmlns:a16="http://schemas.microsoft.com/office/drawing/2014/main" id="{383FB6E6-5B8E-45BE-8DD2-5C0FC4E41BA7}"/>
               </a:ext>
             </a:extLst>
           </p:cNvPr>
@@ -6037,7 +6093,7 @@
         </p:nvSpPr>
         <p:spPr>
           <a:xfrm xmlns:a="http://schemas.openxmlformats.org/drawingml/2006/main">
-            <a:off x="742950" y="5505450"/>
+            <a:off x="742950" y="5353050"/>
             <a:ext cx="10477500" cy="419100"/>
           </a:xfrm>
           <a:prstGeom xmlns:a="http://schemas.openxmlformats.org/drawingml/2006/main" prst="rect">
@@ -6175,7 +6231,7 @@
                 <a:ea typeface="Arial"/>
                 <a:cs typeface="Arial"/>
               </a:rPr>
-              <a:t>Objetivo: que ambas partes consulten el mismo proceso con información actualizada.</a:t>
+              <a:t>Así el estudiante no necesita viajar para que le creen la cuenta.</a:t>
             </a:r>
           </a:p>
         </p:txBody>
@@ -6183,7 +6239,7 @@
     </p:spTree>
     <p:extLst>
       <p:ext uri="{BB962C8B-B14F-4D97-AF65-F5344CB8AC3E}">
-        <p14:creationId xmlns:p14="http://schemas.microsoft.com/office/powerpoint/2010/main" val="1605688535"/>
+        <p14:creationId xmlns:p14="http://schemas.microsoft.com/office/powerpoint/2010/main" val="326605970"/>
       </p:ext>
     </p:extLst>
   </p:cSld>
@@ -6211,16 +6267,16 @@
       </p:grpSpPr>
       <p:cxnSp>
         <p:nvCxnSpPr>
-          <p:cNvPr id="18" name="">
+          <p:cNvPr id="19" name="">
             <a:extLst xmlns:a="http://schemas.openxmlformats.org/drawingml/2006/main">
               <a:ext uri="{FF2B5EF4-FFF2-40B4-BE49-F238E27FC236}">
-                <a16:creationId xmlns:a16="http://schemas.microsoft.com/office/drawing/2014/main" id="{89EFF1D1-AA1B-4796-904B-F8CA1F8606E7}"/>
+                <a16:creationId xmlns:a16="http://schemas.microsoft.com/office/drawing/2014/main" id="{6E7D407E-E2F3-4927-A706-8CC89B046C78}"/>
               </a:ext>
             </a:extLst>
           </p:cNvPr>
           <p:cNvCxnSpPr>
-            <a:stCxn xmlns:a="http://schemas.openxmlformats.org/drawingml/2006/main" id="10" idx="3"/>
-            <a:endCxn xmlns:a="http://schemas.openxmlformats.org/drawingml/2006/main" id="13" idx="1"/>
+            <a:stCxn xmlns:a="http://schemas.openxmlformats.org/drawingml/2006/main" id="11" idx="3"/>
+            <a:endCxn xmlns:a="http://schemas.openxmlformats.org/drawingml/2006/main" id="14" idx="1"/>
           </p:cNvCxnSpPr>
           <p:nvPr/>
         </p:nvCxnSpPr>
@@ -6243,16 +6299,16 @@
       </p:cxnSp>
       <p:cxnSp>
         <p:nvCxnSpPr>
-          <p:cNvPr id="17" name="">
+          <p:cNvPr id="18" name="">
             <a:extLst xmlns:a="http://schemas.openxmlformats.org/drawingml/2006/main">
               <a:ext uri="{FF2B5EF4-FFF2-40B4-BE49-F238E27FC236}">
-                <a16:creationId xmlns:a16="http://schemas.microsoft.com/office/drawing/2014/main" id="{DAD55A54-3855-42CA-977C-3F038791F5F4}"/>
+                <a16:creationId xmlns:a16="http://schemas.microsoft.com/office/drawing/2014/main" id="{20EE6C36-3C0D-4865-84A1-9953347B0F6F}"/>
               </a:ext>
             </a:extLst>
           </p:cNvPr>
           <p:cNvCxnSpPr>
-            <a:stCxn xmlns:a="http://schemas.openxmlformats.org/drawingml/2006/main" id="7" idx="3"/>
-            <a:endCxn xmlns:a="http://schemas.openxmlformats.org/drawingml/2006/main" id="10" idx="1"/>
+            <a:stCxn xmlns:a="http://schemas.openxmlformats.org/drawingml/2006/main" id="8" idx="3"/>
+            <a:endCxn xmlns:a="http://schemas.openxmlformats.org/drawingml/2006/main" id="11" idx="1"/>
           </p:cNvCxnSpPr>
           <p:nvPr/>
         </p:nvCxnSpPr>
@@ -6277,16 +6333,16 @@
       </p:cxnSp>
       <p:cxnSp>
         <p:nvCxnSpPr>
-          <p:cNvPr id="16" name="">
+          <p:cNvPr id="17" name="">
             <a:extLst xmlns:a="http://schemas.openxmlformats.org/drawingml/2006/main">
               <a:ext uri="{FF2B5EF4-FFF2-40B4-BE49-F238E27FC236}">
-                <a16:creationId xmlns:a16="http://schemas.microsoft.com/office/drawing/2014/main" id="{EF9DE519-5F68-4F64-ACA6-3DF18CBC565B}"/>
+                <a16:creationId xmlns:a16="http://schemas.microsoft.com/office/drawing/2014/main" id="{2DAACFC1-DC3F-4D6D-9201-2554A9A093BA}"/>
               </a:ext>
             </a:extLst>
           </p:cNvPr>
           <p:cNvCxnSpPr>
-            <a:stCxn xmlns:a="http://schemas.openxmlformats.org/drawingml/2006/main" id="4" idx="3"/>
-            <a:endCxn xmlns:a="http://schemas.openxmlformats.org/drawingml/2006/main" id="10" idx="1"/>
+            <a:stCxn xmlns:a="http://schemas.openxmlformats.org/drawingml/2006/main" id="5" idx="3"/>
+            <a:endCxn xmlns:a="http://schemas.openxmlformats.org/drawingml/2006/main" id="11" idx="1"/>
           </p:cNvCxnSpPr>
           <p:nvPr/>
         </p:nvCxnSpPr>
@@ -6309,12 +6365,40 @@
           </a:ln>
         </p:spPr>
       </p:cxnSp>
+      <p:pic>
+        <p:nvPicPr>
+          <p:cNvPr id="21" name="">
+            <a:extLst xmlns:a="http://schemas.openxmlformats.org/drawingml/2006/main">
+              <a:ext uri="{FF2B5EF4-FFF2-40B4-BE49-F238E27FC236}">
+                <a16:creationId xmlns:a16="http://schemas.microsoft.com/office/drawing/2014/main" id="{035190DD-B470-4ED1-BB8C-E558763C47B5}"/>
+              </a:ext>
+            </a:extLst>
+          </p:cNvPr>
+          <p:cNvPicPr>
+            <a:picLocks xmlns:a="http://schemas.openxmlformats.org/drawingml/2006/main" noChangeAspect="1"/>
+          </p:cNvPicPr>
+          <p:nvPr/>
+        </p:nvPicPr>
+        <p:blipFill>
+          <a:blip xmlns:r="http://schemas.openxmlformats.org/officeDocument/2006/relationships" xmlns:a="http://schemas.openxmlformats.org/drawingml/2006/main" r:embed="R13a03c28e7354a1f"/>
+          <a:stretch xmlns:a="http://schemas.openxmlformats.org/drawingml/2006/main"/>
+        </p:blipFill>
+        <p:spPr>
+          <a:xfrm xmlns:a="http://schemas.openxmlformats.org/drawingml/2006/main">
+            <a:off x="11096625" y="171450"/>
+            <a:ext cx="381000" cy="381000"/>
+          </a:xfrm>
+          <a:prstGeom xmlns:a="http://schemas.openxmlformats.org/drawingml/2006/main" prst="rect">
+            <a:avLst/>
+          </a:prstGeom>
+        </p:spPr>
+      </p:pic>
       <p:sp>
         <p:nvSpPr>
-          <p:cNvPr id="20" name="footer-3">
+          <p:cNvPr id="2" name="footer-3">
             <a:extLst xmlns:a="http://schemas.openxmlformats.org/drawingml/2006/main">
               <a:ext uri="{FF2B5EF4-FFF2-40B4-BE49-F238E27FC236}">
-                <a16:creationId xmlns:a16="http://schemas.microsoft.com/office/drawing/2014/main" id="{FCB42BEE-AAE8-49AB-9976-4276E26D1A66}"/>
+                <a16:creationId xmlns:a16="http://schemas.microsoft.com/office/drawing/2014/main" id="{D5477BD0-C2E9-49D2-B743-779F9874E61B}"/>
               </a:ext>
             </a:extLst>
           </p:cNvPr>
@@ -6470,10 +6554,10 @@
       </p:sp>
       <p:sp>
         <p:nvSpPr>
-          <p:cNvPr id="2" name="slide-title">
+          <p:cNvPr id="3" name="slide-title">
             <a:extLst xmlns:a="http://schemas.openxmlformats.org/drawingml/2006/main">
               <a:ext uri="{FF2B5EF4-FFF2-40B4-BE49-F238E27FC236}">
-                <a16:creationId xmlns:a16="http://schemas.microsoft.com/office/drawing/2014/main" id="{E6B7BB4C-F161-4D90-87D7-D8254BB3935C}"/>
+                <a16:creationId xmlns:a16="http://schemas.microsoft.com/office/drawing/2014/main" id="{39210ECC-0AE6-4B71-85CC-ABD03B4ABACF}"/>
               </a:ext>
             </a:extLst>
           </p:cNvPr>
@@ -6629,10 +6713,10 @@
       </p:sp>
       <p:sp>
         <p:nvSpPr>
-          <p:cNvPr id="3" name="architecture-subtitle">
+          <p:cNvPr id="4" name="architecture-subtitle">
             <a:extLst xmlns:a="http://schemas.openxmlformats.org/drawingml/2006/main">
               <a:ext uri="{FF2B5EF4-FFF2-40B4-BE49-F238E27FC236}">
-                <a16:creationId xmlns:a16="http://schemas.microsoft.com/office/drawing/2014/main" id="{74088349-FE4D-4009-9229-1CE00386A671}"/>
+                <a16:creationId xmlns:a16="http://schemas.microsoft.com/office/drawing/2014/main" id="{FE413B68-465E-4534-BE3B-1B1478DA333A}"/>
               </a:ext>
             </a:extLst>
           </p:cNvPr>
@@ -6781,17 +6865,17 @@
                 <a:ea typeface="Arial"/>
                 <a:cs typeface="Arial"/>
               </a:rPr>
-              <a:t>El equipo puede administrar desde web o escritorio; ambas aplicaciones usan las mismas entidades</a:t>
+              <a:t>Web y escritorio usan la misma base SQL Server, llamada NBU en la instancia local SQLEXPRESS22</a:t>
             </a:r>
           </a:p>
         </p:txBody>
       </p:sp>
       <p:sp>
         <p:nvSpPr>
-          <p:cNvPr id="4" name="web-app">
+          <p:cNvPr id="5" name="web-app">
             <a:extLst xmlns:a="http://schemas.openxmlformats.org/drawingml/2006/main">
               <a:ext uri="{FF2B5EF4-FFF2-40B4-BE49-F238E27FC236}">
-                <a16:creationId xmlns:a16="http://schemas.microsoft.com/office/drawing/2014/main" id="{C38D1380-EA48-41F6-840C-04D389195226}"/>
+                <a16:creationId xmlns:a16="http://schemas.microsoft.com/office/drawing/2014/main" id="{86147BD3-6932-4240-A5DE-48CF9E7A3520}"/>
               </a:ext>
             </a:extLst>
           </p:cNvPr>
@@ -6823,10 +6907,10 @@
       </p:sp>
       <p:sp>
         <p:nvSpPr>
-          <p:cNvPr id="5" name="web-app-label">
+          <p:cNvPr id="6" name="web-app-label">
             <a:extLst xmlns:a="http://schemas.openxmlformats.org/drawingml/2006/main">
               <a:ext uri="{FF2B5EF4-FFF2-40B4-BE49-F238E27FC236}">
-                <a16:creationId xmlns:a16="http://schemas.microsoft.com/office/drawing/2014/main" id="{54E6882E-3687-4503-899E-DCF43C728613}"/>
+                <a16:creationId xmlns:a16="http://schemas.microsoft.com/office/drawing/2014/main" id="{D1E5E76A-E5B1-451E-B163-402742E3F508}"/>
               </a:ext>
             </a:extLst>
           </p:cNvPr>
@@ -6982,10 +7066,10 @@
       </p:sp>
       <p:sp>
         <p:nvSpPr>
-          <p:cNvPr id="6" name="web-app-description">
+          <p:cNvPr id="7" name="web-app-description">
             <a:extLst xmlns:a="http://schemas.openxmlformats.org/drawingml/2006/main">
               <a:ext uri="{FF2B5EF4-FFF2-40B4-BE49-F238E27FC236}">
-                <a16:creationId xmlns:a16="http://schemas.microsoft.com/office/drawing/2014/main" id="{B6084335-9F4F-4D0A-B9F1-60635017A30A}"/>
+                <a16:creationId xmlns:a16="http://schemas.microsoft.com/office/drawing/2014/main" id="{BA3A9572-F070-4717-9633-46C5548B7695}"/>
               </a:ext>
             </a:extLst>
           </p:cNvPr>
@@ -7141,10 +7225,10 @@
       </p:sp>
       <p:sp>
         <p:nvSpPr>
-          <p:cNvPr id="7" name="desktop-app">
+          <p:cNvPr id="8" name="desktop-app">
             <a:extLst xmlns:a="http://schemas.openxmlformats.org/drawingml/2006/main">
               <a:ext uri="{FF2B5EF4-FFF2-40B4-BE49-F238E27FC236}">
-                <a16:creationId xmlns:a16="http://schemas.microsoft.com/office/drawing/2014/main" id="{2AC3D444-62B9-4F05-9A97-AC4AAE5228C4}"/>
+                <a16:creationId xmlns:a16="http://schemas.microsoft.com/office/drawing/2014/main" id="{438BB9D6-7DD4-449B-B9AE-573190233894}"/>
               </a:ext>
             </a:extLst>
           </p:cNvPr>
@@ -7176,10 +7260,10 @@
       </p:sp>
       <p:sp>
         <p:nvSpPr>
-          <p:cNvPr id="8" name="desktop-app-label">
+          <p:cNvPr id="9" name="desktop-app-label">
             <a:extLst xmlns:a="http://schemas.openxmlformats.org/drawingml/2006/main">
               <a:ext uri="{FF2B5EF4-FFF2-40B4-BE49-F238E27FC236}">
-                <a16:creationId xmlns:a16="http://schemas.microsoft.com/office/drawing/2014/main" id="{40E21265-AC58-4B8B-874B-BD927A5F4FCB}"/>
+                <a16:creationId xmlns:a16="http://schemas.microsoft.com/office/drawing/2014/main" id="{4414D5EF-CF69-42D3-82FA-01A29D0A1AAB}"/>
               </a:ext>
             </a:extLst>
           </p:cNvPr>
@@ -7335,10 +7419,10 @@
       </p:sp>
       <p:sp>
         <p:nvSpPr>
-          <p:cNvPr id="9" name="desktop-app-description">
+          <p:cNvPr id="10" name="desktop-app-description">
             <a:extLst xmlns:a="http://schemas.openxmlformats.org/drawingml/2006/main">
               <a:ext uri="{FF2B5EF4-FFF2-40B4-BE49-F238E27FC236}">
-                <a16:creationId xmlns:a16="http://schemas.microsoft.com/office/drawing/2014/main" id="{F885F229-4464-498B-9C7F-0C1A93FA557D}"/>
+                <a16:creationId xmlns:a16="http://schemas.microsoft.com/office/drawing/2014/main" id="{622E936D-38A2-452A-B2F1-74FBAEEE2FC8}"/>
               </a:ext>
             </a:extLst>
           </p:cNvPr>
@@ -7494,10 +7578,10 @@
       </p:sp>
       <p:sp>
         <p:nvSpPr>
-          <p:cNvPr id="10" name="shared-data">
+          <p:cNvPr id="11" name="shared-data">
             <a:extLst xmlns:a="http://schemas.openxmlformats.org/drawingml/2006/main">
               <a:ext uri="{FF2B5EF4-FFF2-40B4-BE49-F238E27FC236}">
-                <a16:creationId xmlns:a16="http://schemas.microsoft.com/office/drawing/2014/main" id="{06852884-3963-45FF-B4C8-6C19EF5E68C3}"/>
+                <a16:creationId xmlns:a16="http://schemas.microsoft.com/office/drawing/2014/main" id="{2F135680-2177-4060-B20B-EBDE127F6B2E}"/>
               </a:ext>
             </a:extLst>
           </p:cNvPr>
@@ -7529,10 +7613,10 @@
       </p:sp>
       <p:sp>
         <p:nvSpPr>
-          <p:cNvPr id="11" name="shared-data-label">
+          <p:cNvPr id="12" name="shared-data-label">
             <a:extLst xmlns:a="http://schemas.openxmlformats.org/drawingml/2006/main">
               <a:ext uri="{FF2B5EF4-FFF2-40B4-BE49-F238E27FC236}">
-                <a16:creationId xmlns:a16="http://schemas.microsoft.com/office/drawing/2014/main" id="{D4399794-D1EE-4B12-A6E7-5E4C95B8268F}"/>
+                <a16:creationId xmlns:a16="http://schemas.microsoft.com/office/drawing/2014/main" id="{C0F3AAC9-A78D-4A5E-8AB0-B356D678D554}"/>
               </a:ext>
             </a:extLst>
           </p:cNvPr>
@@ -7688,10 +7772,10 @@
       </p:sp>
       <p:sp>
         <p:nvSpPr>
-          <p:cNvPr id="12" name="shared-data-description">
+          <p:cNvPr id="13" name="shared-data-description">
             <a:extLst xmlns:a="http://schemas.openxmlformats.org/drawingml/2006/main">
               <a:ext uri="{FF2B5EF4-FFF2-40B4-BE49-F238E27FC236}">
-                <a16:creationId xmlns:a16="http://schemas.microsoft.com/office/drawing/2014/main" id="{3E78C14C-5977-4649-9F68-CCFD41DEF56E}"/>
+                <a16:creationId xmlns:a16="http://schemas.microsoft.com/office/drawing/2014/main" id="{9236178C-74B1-4837-83E3-7CA91F5E30CD}"/>
               </a:ext>
             </a:extLst>
           </p:cNvPr>
@@ -7847,10 +7931,10 @@
       </p:sp>
       <p:sp>
         <p:nvSpPr>
-          <p:cNvPr id="13" name="sql-server">
+          <p:cNvPr id="14" name="sql-server">
             <a:extLst xmlns:a="http://schemas.openxmlformats.org/drawingml/2006/main">
               <a:ext uri="{FF2B5EF4-FFF2-40B4-BE49-F238E27FC236}">
-                <a16:creationId xmlns:a16="http://schemas.microsoft.com/office/drawing/2014/main" id="{1E5D90D0-9F14-409A-B1C8-4355C0C85BE1}"/>
+                <a16:creationId xmlns:a16="http://schemas.microsoft.com/office/drawing/2014/main" id="{4E654373-B3CA-4B9E-AAF0-9E5835234F3F}"/>
               </a:ext>
             </a:extLst>
           </p:cNvPr>
@@ -7882,10 +7966,10 @@
       </p:sp>
       <p:sp>
         <p:nvSpPr>
-          <p:cNvPr id="14" name="sql-server-label">
+          <p:cNvPr id="15" name="sql-server-label">
             <a:extLst xmlns:a="http://schemas.openxmlformats.org/drawingml/2006/main">
               <a:ext uri="{FF2B5EF4-FFF2-40B4-BE49-F238E27FC236}">
-                <a16:creationId xmlns:a16="http://schemas.microsoft.com/office/drawing/2014/main" id="{8EDB7807-63D7-46CD-A1EB-BB4FA8F52F5C}"/>
+                <a16:creationId xmlns:a16="http://schemas.microsoft.com/office/drawing/2014/main" id="{11E4CD4E-260F-4F70-969C-2EB041EB8EFA}"/>
               </a:ext>
             </a:extLst>
           </p:cNvPr>
@@ -8041,10 +8125,10 @@
       </p:sp>
       <p:sp>
         <p:nvSpPr>
-          <p:cNvPr id="15" name="sql-server-description">
+          <p:cNvPr id="16" name="sql-server-description">
             <a:extLst xmlns:a="http://schemas.openxmlformats.org/drawingml/2006/main">
               <a:ext uri="{FF2B5EF4-FFF2-40B4-BE49-F238E27FC236}">
-                <a16:creationId xmlns:a16="http://schemas.microsoft.com/office/drawing/2014/main" id="{576A3514-FC17-4D8C-86CF-7184C8B1CFCE}"/>
+                <a16:creationId xmlns:a16="http://schemas.microsoft.com/office/drawing/2014/main" id="{5AB707D3-1906-4E0E-881D-D0F7911F9EDB}"/>
               </a:ext>
             </a:extLst>
           </p:cNvPr>
@@ -8193,17 +8277,17 @@
                 <a:ea typeface="Arial"/>
                 <a:cs typeface="Arial"/>
               </a:rPr>
-              <a:t>Base de datos común</a:t>
+              <a:t>Base NBU · SQLEXPRESS22</a:t>
             </a:r>
           </a:p>
         </p:txBody>
       </p:sp>
       <p:sp>
         <p:nvSpPr>
-          <p:cNvPr id="19" name="architecture-caption">
+          <p:cNvPr id="20" name="architecture-caption">
             <a:extLst xmlns:a="http://schemas.openxmlformats.org/drawingml/2006/main">
               <a:ext uri="{FF2B5EF4-FFF2-40B4-BE49-F238E27FC236}">
-                <a16:creationId xmlns:a16="http://schemas.microsoft.com/office/drawing/2014/main" id="{AA0375C4-05F0-4150-B80E-49224A26D3BC}"/>
+                <a16:creationId xmlns:a16="http://schemas.microsoft.com/office/drawing/2014/main" id="{4886A2B5-8405-4FF8-B27E-4B3A0114DA79}"/>
               </a:ext>
             </a:extLst>
           </p:cNvPr>
@@ -8360,7 +8444,7 @@
     </p:spTree>
     <p:extLst>
       <p:ext uri="{BB962C8B-B14F-4D97-AF65-F5344CB8AC3E}">
-        <p14:creationId xmlns:p14="http://schemas.microsoft.com/office/powerpoint/2010/main" val="211848653"/>
+        <p14:creationId xmlns:p14="http://schemas.microsoft.com/office/powerpoint/2010/main" val="9211062"/>
       </p:ext>
     </p:extLst>
   </p:cSld>
@@ -8386,12 +8470,40 @@
       <p:grpSpPr>
         <a:xfrm xmlns:a="http://schemas.openxmlformats.org/drawingml/2006/main"/>
       </p:grpSpPr>
+      <p:pic>
+        <p:nvPicPr>
+          <p:cNvPr id="16" name="">
+            <a:extLst xmlns:a="http://schemas.openxmlformats.org/drawingml/2006/main">
+              <a:ext uri="{FF2B5EF4-FFF2-40B4-BE49-F238E27FC236}">
+                <a16:creationId xmlns:a16="http://schemas.microsoft.com/office/drawing/2014/main" id="{67B68304-5F8D-4BF7-B7F9-7162413B935D}"/>
+              </a:ext>
+            </a:extLst>
+          </p:cNvPr>
+          <p:cNvPicPr>
+            <a:picLocks xmlns:a="http://schemas.openxmlformats.org/drawingml/2006/main" noChangeAspect="1"/>
+          </p:cNvPicPr>
+          <p:nvPr/>
+        </p:nvPicPr>
+        <p:blipFill>
+          <a:blip xmlns:r="http://schemas.openxmlformats.org/officeDocument/2006/relationships" xmlns:a="http://schemas.openxmlformats.org/drawingml/2006/main" r:embed="R05d8826266024e64"/>
+          <a:stretch xmlns:a="http://schemas.openxmlformats.org/drawingml/2006/main"/>
+        </p:blipFill>
+        <p:spPr>
+          <a:xfrm xmlns:a="http://schemas.openxmlformats.org/drawingml/2006/main">
+            <a:off x="11096625" y="171450"/>
+            <a:ext cx="381000" cy="381000"/>
+          </a:xfrm>
+          <a:prstGeom xmlns:a="http://schemas.openxmlformats.org/drawingml/2006/main" prst="rect">
+            <a:avLst/>
+          </a:prstGeom>
+        </p:spPr>
+      </p:pic>
       <p:sp>
         <p:nvSpPr>
-          <p:cNvPr id="15" name="footer-4">
+          <p:cNvPr id="2" name="footer-4">
             <a:extLst xmlns:a="http://schemas.openxmlformats.org/drawingml/2006/main">
               <a:ext uri="{FF2B5EF4-FFF2-40B4-BE49-F238E27FC236}">
-                <a16:creationId xmlns:a16="http://schemas.microsoft.com/office/drawing/2014/main" id="{3072B7AA-B7B2-44E7-9E17-6E3920AC4E52}"/>
+                <a16:creationId xmlns:a16="http://schemas.microsoft.com/office/drawing/2014/main" id="{FEC0801E-1F60-4B40-869C-A8B66AD07526}"/>
               </a:ext>
             </a:extLst>
           </p:cNvPr>
@@ -8547,10 +8659,10 @@
       </p:sp>
       <p:sp>
         <p:nvSpPr>
-          <p:cNvPr id="2" name="slide-title">
+          <p:cNvPr id="3" name="slide-title">
             <a:extLst xmlns:a="http://schemas.openxmlformats.org/drawingml/2006/main">
               <a:ext uri="{FF2B5EF4-FFF2-40B4-BE49-F238E27FC236}">
-                <a16:creationId xmlns:a16="http://schemas.microsoft.com/office/drawing/2014/main" id="{6F8D9307-C5F4-48E7-A524-067B30694348}"/>
+                <a16:creationId xmlns:a16="http://schemas.microsoft.com/office/drawing/2014/main" id="{F5431CBD-F1E0-474E-A4CE-1C0923A9861F}"/>
               </a:ext>
             </a:extLst>
           </p:cNvPr>
@@ -8706,10 +8818,10 @@
       </p:sp>
       <p:sp>
         <p:nvSpPr>
-          <p:cNvPr id="3" name="module-01-number">
+          <p:cNvPr id="4" name="module-01-number">
             <a:extLst xmlns:a="http://schemas.openxmlformats.org/drawingml/2006/main">
               <a:ext uri="{FF2B5EF4-FFF2-40B4-BE49-F238E27FC236}">
-                <a16:creationId xmlns:a16="http://schemas.microsoft.com/office/drawing/2014/main" id="{7D3AF7E2-162F-443B-8D87-39CAFB23EAA2}"/>
+                <a16:creationId xmlns:a16="http://schemas.microsoft.com/office/drawing/2014/main" id="{1BD23983-A842-436C-AFFE-228FAD4F5796}"/>
               </a:ext>
             </a:extLst>
           </p:cNvPr>
@@ -8865,10 +8977,10 @@
       </p:sp>
       <p:sp>
         <p:nvSpPr>
-          <p:cNvPr id="4" name="module-01-name">
+          <p:cNvPr id="5" name="module-01-name">
             <a:extLst xmlns:a="http://schemas.openxmlformats.org/drawingml/2006/main">
               <a:ext uri="{FF2B5EF4-FFF2-40B4-BE49-F238E27FC236}">
-                <a16:creationId xmlns:a16="http://schemas.microsoft.com/office/drawing/2014/main" id="{379DB9A7-4899-4D56-944C-72E5D7E34B67}"/>
+                <a16:creationId xmlns:a16="http://schemas.microsoft.com/office/drawing/2014/main" id="{9F71CF8D-558E-41AB-B3C0-3AB495D96BFC}"/>
               </a:ext>
             </a:extLst>
           </p:cNvPr>
@@ -9024,10 +9136,10 @@
       </p:sp>
       <p:sp>
         <p:nvSpPr>
-          <p:cNvPr id="5" name="module-01-description">
+          <p:cNvPr id="6" name="module-01-description">
             <a:extLst xmlns:a="http://schemas.openxmlformats.org/drawingml/2006/main">
               <a:ext uri="{FF2B5EF4-FFF2-40B4-BE49-F238E27FC236}">
-                <a16:creationId xmlns:a16="http://schemas.microsoft.com/office/drawing/2014/main" id="{405F4A1E-FB9B-41B1-AF32-BEA8DFDC4149}"/>
+                <a16:creationId xmlns:a16="http://schemas.microsoft.com/office/drawing/2014/main" id="{5EF469B4-6313-4D32-BF7A-321F4833CA7C}"/>
               </a:ext>
             </a:extLst>
           </p:cNvPr>
@@ -9187,10 +9299,10 @@
       </p:sp>
       <p:sp>
         <p:nvSpPr>
-          <p:cNvPr id="6" name="module-02-number">
+          <p:cNvPr id="7" name="module-02-number">
             <a:extLst xmlns:a="http://schemas.openxmlformats.org/drawingml/2006/main">
               <a:ext uri="{FF2B5EF4-FFF2-40B4-BE49-F238E27FC236}">
-                <a16:creationId xmlns:a16="http://schemas.microsoft.com/office/drawing/2014/main" id="{2442E9DC-E846-49AF-B5E2-E184F4D1F436}"/>
+                <a16:creationId xmlns:a16="http://schemas.microsoft.com/office/drawing/2014/main" id="{1C87AAE0-F830-49ED-AFED-2B9C546FAC5D}"/>
               </a:ext>
             </a:extLst>
           </p:cNvPr>
@@ -9346,10 +9458,10 @@
       </p:sp>
       <p:sp>
         <p:nvSpPr>
-          <p:cNvPr id="7" name="module-02-name">
+          <p:cNvPr id="8" name="module-02-name">
             <a:extLst xmlns:a="http://schemas.openxmlformats.org/drawingml/2006/main">
               <a:ext uri="{FF2B5EF4-FFF2-40B4-BE49-F238E27FC236}">
-                <a16:creationId xmlns:a16="http://schemas.microsoft.com/office/drawing/2014/main" id="{04AAE7BF-E32E-480B-9D8D-42DBBE886DF4}"/>
+                <a16:creationId xmlns:a16="http://schemas.microsoft.com/office/drawing/2014/main" id="{6F1BAFA2-C72B-4509-AAC2-EBDA78F8BE6E}"/>
               </a:ext>
             </a:extLst>
           </p:cNvPr>
@@ -9505,10 +9617,10 @@
       </p:sp>
       <p:sp>
         <p:nvSpPr>
-          <p:cNvPr id="8" name="module-02-description">
+          <p:cNvPr id="9" name="module-02-description">
             <a:extLst xmlns:a="http://schemas.openxmlformats.org/drawingml/2006/main">
               <a:ext uri="{FF2B5EF4-FFF2-40B4-BE49-F238E27FC236}">
-                <a16:creationId xmlns:a16="http://schemas.microsoft.com/office/drawing/2014/main" id="{DBDB5205-331C-46A5-A348-20D43BD4481E}"/>
+                <a16:creationId xmlns:a16="http://schemas.microsoft.com/office/drawing/2014/main" id="{14996FAB-1CF9-4037-AD46-B05355DB5676}"/>
               </a:ext>
             </a:extLst>
           </p:cNvPr>
@@ -9668,10 +9780,10 @@
       </p:sp>
       <p:sp>
         <p:nvSpPr>
-          <p:cNvPr id="9" name="module-03-number">
+          <p:cNvPr id="10" name="module-03-number">
             <a:extLst xmlns:a="http://schemas.openxmlformats.org/drawingml/2006/main">
               <a:ext uri="{FF2B5EF4-FFF2-40B4-BE49-F238E27FC236}">
-                <a16:creationId xmlns:a16="http://schemas.microsoft.com/office/drawing/2014/main" id="{6491F74B-6CB4-414C-9188-AC13082409E7}"/>
+                <a16:creationId xmlns:a16="http://schemas.microsoft.com/office/drawing/2014/main" id="{E8ABA8AF-635F-413F-80DC-F777A36594F0}"/>
               </a:ext>
             </a:extLst>
           </p:cNvPr>
@@ -9827,10 +9939,10 @@
       </p:sp>
       <p:sp>
         <p:nvSpPr>
-          <p:cNvPr id="10" name="module-03-name">
+          <p:cNvPr id="11" name="module-03-name">
             <a:extLst xmlns:a="http://schemas.openxmlformats.org/drawingml/2006/main">
               <a:ext uri="{FF2B5EF4-FFF2-40B4-BE49-F238E27FC236}">
-                <a16:creationId xmlns:a16="http://schemas.microsoft.com/office/drawing/2014/main" id="{46A63F3B-B528-4F77-A2D8-4661FDBAFA7C}"/>
+                <a16:creationId xmlns:a16="http://schemas.microsoft.com/office/drawing/2014/main" id="{5FAC9377-E8BB-4B24-BD80-3467D3D44603}"/>
               </a:ext>
             </a:extLst>
           </p:cNvPr>
@@ -9986,10 +10098,10 @@
       </p:sp>
       <p:sp>
         <p:nvSpPr>
-          <p:cNvPr id="11" name="module-03-description">
+          <p:cNvPr id="12" name="module-03-description">
             <a:extLst xmlns:a="http://schemas.openxmlformats.org/drawingml/2006/main">
               <a:ext uri="{FF2B5EF4-FFF2-40B4-BE49-F238E27FC236}">
-                <a16:creationId xmlns:a16="http://schemas.microsoft.com/office/drawing/2014/main" id="{8D085566-C5A7-4D1C-BC43-367D7F60733E}"/>
+                <a16:creationId xmlns:a16="http://schemas.microsoft.com/office/drawing/2014/main" id="{58129DCB-7A9F-4F7E-B9A3-6F377900583B}"/>
               </a:ext>
             </a:extLst>
           </p:cNvPr>
@@ -10149,10 +10261,10 @@
       </p:sp>
       <p:sp>
         <p:nvSpPr>
-          <p:cNvPr id="12" name="module-04-number">
+          <p:cNvPr id="13" name="module-04-number">
             <a:extLst xmlns:a="http://schemas.openxmlformats.org/drawingml/2006/main">
               <a:ext uri="{FF2B5EF4-FFF2-40B4-BE49-F238E27FC236}">
-                <a16:creationId xmlns:a16="http://schemas.microsoft.com/office/drawing/2014/main" id="{C8B687B8-46D5-480E-A936-33CAC4C5BEC4}"/>
+                <a16:creationId xmlns:a16="http://schemas.microsoft.com/office/drawing/2014/main" id="{6A787873-8F86-4DDD-85DC-55137D446E0E}"/>
               </a:ext>
             </a:extLst>
           </p:cNvPr>
@@ -10308,10 +10420,10 @@
       </p:sp>
       <p:sp>
         <p:nvSpPr>
-          <p:cNvPr id="13" name="module-04-name">
+          <p:cNvPr id="14" name="module-04-name">
             <a:extLst xmlns:a="http://schemas.openxmlformats.org/drawingml/2006/main">
               <a:ext uri="{FF2B5EF4-FFF2-40B4-BE49-F238E27FC236}">
-                <a16:creationId xmlns:a16="http://schemas.microsoft.com/office/drawing/2014/main" id="{61379B53-AD9F-47E7-B3D6-E4199BD81996}"/>
+                <a16:creationId xmlns:a16="http://schemas.microsoft.com/office/drawing/2014/main" id="{97CCBF95-6B9D-44DE-A582-D79D3C945AA7}"/>
               </a:ext>
             </a:extLst>
           </p:cNvPr>
@@ -10467,10 +10579,10 @@
       </p:sp>
       <p:sp>
         <p:nvSpPr>
-          <p:cNvPr id="14" name="module-04-description">
+          <p:cNvPr id="15" name="module-04-description">
             <a:extLst xmlns:a="http://schemas.openxmlformats.org/drawingml/2006/main">
               <a:ext uri="{FF2B5EF4-FFF2-40B4-BE49-F238E27FC236}">
-                <a16:creationId xmlns:a16="http://schemas.microsoft.com/office/drawing/2014/main" id="{EFA2E015-380C-4212-A0BC-8A725D2888DE}"/>
+                <a16:creationId xmlns:a16="http://schemas.microsoft.com/office/drawing/2014/main" id="{B873C5F3-DFA4-4025-8C2C-8820067A2D55}"/>
               </a:ext>
             </a:extLst>
           </p:cNvPr>
@@ -10631,7 +10743,7 @@
     </p:spTree>
     <p:extLst>
       <p:ext uri="{BB962C8B-B14F-4D97-AF65-F5344CB8AC3E}">
-        <p14:creationId xmlns:p14="http://schemas.microsoft.com/office/powerpoint/2010/main" val="1543490321"/>
+        <p14:creationId xmlns:p14="http://schemas.microsoft.com/office/powerpoint/2010/main" val="1255118769"/>
       </p:ext>
     </p:extLst>
   </p:cSld>
@@ -10657,12 +10769,40 @@
       <p:grpSpPr>
         <a:xfrm xmlns:a="http://schemas.openxmlformats.org/drawingml/2006/main"/>
       </p:grpSpPr>
+      <p:pic>
+        <p:nvPicPr>
+          <p:cNvPr id="17" name="">
+            <a:extLst xmlns:a="http://schemas.openxmlformats.org/drawingml/2006/main">
+              <a:ext uri="{FF2B5EF4-FFF2-40B4-BE49-F238E27FC236}">
+                <a16:creationId xmlns:a16="http://schemas.microsoft.com/office/drawing/2014/main" id="{4DE433CC-2ACA-459D-AE86-AB960FF04814}"/>
+              </a:ext>
+            </a:extLst>
+          </p:cNvPr>
+          <p:cNvPicPr>
+            <a:picLocks xmlns:a="http://schemas.openxmlformats.org/drawingml/2006/main" noChangeAspect="1"/>
+          </p:cNvPicPr>
+          <p:nvPr/>
+        </p:nvPicPr>
+        <p:blipFill>
+          <a:blip xmlns:r="http://schemas.openxmlformats.org/officeDocument/2006/relationships" xmlns:a="http://schemas.openxmlformats.org/drawingml/2006/main" r:embed="R36a851a68ae74a07"/>
+          <a:stretch xmlns:a="http://schemas.openxmlformats.org/drawingml/2006/main"/>
+        </p:blipFill>
+        <p:spPr>
+          <a:xfrm xmlns:a="http://schemas.openxmlformats.org/drawingml/2006/main">
+            <a:off x="11096625" y="171450"/>
+            <a:ext cx="381000" cy="381000"/>
+          </a:xfrm>
+          <a:prstGeom xmlns:a="http://schemas.openxmlformats.org/drawingml/2006/main" prst="rect">
+            <a:avLst/>
+          </a:prstGeom>
+        </p:spPr>
+      </p:pic>
       <p:sp>
         <p:nvSpPr>
-          <p:cNvPr id="16" name="footer-5">
+          <p:cNvPr id="2" name="footer-5">
             <a:extLst xmlns:a="http://schemas.openxmlformats.org/drawingml/2006/main">
               <a:ext uri="{FF2B5EF4-FFF2-40B4-BE49-F238E27FC236}">
-                <a16:creationId xmlns:a16="http://schemas.microsoft.com/office/drawing/2014/main" id="{64AA4D9D-D35C-4C38-A75E-96303E2AE76A}"/>
+                <a16:creationId xmlns:a16="http://schemas.microsoft.com/office/drawing/2014/main" id="{E0103199-6BC0-4C00-99CB-1542FDFD3C7C}"/>
               </a:ext>
             </a:extLst>
           </p:cNvPr>
@@ -10818,10 +10958,10 @@
       </p:sp>
       <p:sp>
         <p:nvSpPr>
-          <p:cNvPr id="2" name="slide-title">
+          <p:cNvPr id="3" name="slide-title">
             <a:extLst xmlns:a="http://schemas.openxmlformats.org/drawingml/2006/main">
               <a:ext uri="{FF2B5EF4-FFF2-40B4-BE49-F238E27FC236}">
-                <a16:creationId xmlns:a16="http://schemas.microsoft.com/office/drawing/2014/main" id="{ABB08459-914B-44E5-A402-CE93720B1ACE}"/>
+                <a16:creationId xmlns:a16="http://schemas.microsoft.com/office/drawing/2014/main" id="{81F475B6-67E0-4D2B-A3A6-56A37BD2C19D}"/>
               </a:ext>
             </a:extLst>
           </p:cNvPr>
@@ -10970,17 +11110,17 @@
                 <a:ea typeface="Arial"/>
                 <a:cs typeface="Arial"/>
               </a:rPr>
-              <a:t>Recorrido del estudiante</a:t>
+              <a:t>El estudiante usa el portal web</a:t>
             </a:r>
           </a:p>
         </p:txBody>
       </p:sp>
       <p:sp>
         <p:nvSpPr>
-          <p:cNvPr id="3" name="portal-label">
+          <p:cNvPr id="4" name="portal-label">
             <a:extLst xmlns:a="http://schemas.openxmlformats.org/drawingml/2006/main">
               <a:ext uri="{FF2B5EF4-FFF2-40B4-BE49-F238E27FC236}">
-                <a16:creationId xmlns:a16="http://schemas.microsoft.com/office/drawing/2014/main" id="{372C0BF4-0628-4CAD-8459-61B9228394ED}"/>
+                <a16:creationId xmlns:a16="http://schemas.microsoft.com/office/drawing/2014/main" id="{E2E4ACB7-4D41-409E-ABC9-CD5446E83D19}"/>
               </a:ext>
             </a:extLst>
           </p:cNvPr>
@@ -11129,17 +11269,17 @@
                 <a:ea typeface="Arial"/>
                 <a:cs typeface="Arial"/>
               </a:rPr>
-              <a:t>PORTAL WEB ADAPTABLE A CELULAR</a:t>
+              <a:t>PANTALLA ADAPTABLE A CELULAR</a:t>
             </a:r>
           </a:p>
         </p:txBody>
       </p:sp>
       <p:sp>
         <p:nvSpPr>
-          <p:cNvPr id="4" name="journey-01-number">
+          <p:cNvPr id="5" name="journey-01-number">
             <a:extLst xmlns:a="http://schemas.openxmlformats.org/drawingml/2006/main">
               <a:ext uri="{FF2B5EF4-FFF2-40B4-BE49-F238E27FC236}">
-                <a16:creationId xmlns:a16="http://schemas.microsoft.com/office/drawing/2014/main" id="{A05BD4AF-CB67-43A7-B255-80BEF32AB779}"/>
+                <a16:creationId xmlns:a16="http://schemas.microsoft.com/office/drawing/2014/main" id="{AF81BD79-5D33-4BCB-864A-667CEA6951B1}"/>
               </a:ext>
             </a:extLst>
           </p:cNvPr>
@@ -11295,10 +11435,10 @@
       </p:sp>
       <p:sp>
         <p:nvSpPr>
-          <p:cNvPr id="5" name="journey-01-label">
+          <p:cNvPr id="6" name="journey-01-label">
             <a:extLst xmlns:a="http://schemas.openxmlformats.org/drawingml/2006/main">
               <a:ext uri="{FF2B5EF4-FFF2-40B4-BE49-F238E27FC236}">
-                <a16:creationId xmlns:a16="http://schemas.microsoft.com/office/drawing/2014/main" id="{7977F7DB-37E8-44F0-B59B-2F64ED779C6E}"/>
+                <a16:creationId xmlns:a16="http://schemas.microsoft.com/office/drawing/2014/main" id="{B599CEB2-DFE5-4E2E-81AF-333AABB97D1C}"/>
               </a:ext>
             </a:extLst>
           </p:cNvPr>
@@ -11447,17 +11587,17 @@
                 <a:ea typeface="Arial"/>
                 <a:cs typeface="Arial"/>
               </a:rPr>
-              <a:t>Inicia sesión</a:t>
+              <a:t>Inicia sesión tras la aprobación</a:t>
             </a:r>
           </a:p>
         </p:txBody>
       </p:sp>
       <p:sp>
         <p:nvSpPr>
-          <p:cNvPr id="6" name="journey-02-number">
+          <p:cNvPr id="7" name="journey-02-number">
             <a:extLst xmlns:a="http://schemas.openxmlformats.org/drawingml/2006/main">
               <a:ext uri="{FF2B5EF4-FFF2-40B4-BE49-F238E27FC236}">
-                <a16:creationId xmlns:a16="http://schemas.microsoft.com/office/drawing/2014/main" id="{D60D9187-7696-4A63-8B87-B9D844F7F70B}"/>
+                <a16:creationId xmlns:a16="http://schemas.microsoft.com/office/drawing/2014/main" id="{285A95CC-9A61-488C-ABB9-6E9592EA189C}"/>
               </a:ext>
             </a:extLst>
           </p:cNvPr>
@@ -11613,10 +11753,10 @@
       </p:sp>
       <p:sp>
         <p:nvSpPr>
-          <p:cNvPr id="7" name="journey-02-label">
+          <p:cNvPr id="8" name="journey-02-label">
             <a:extLst xmlns:a="http://schemas.openxmlformats.org/drawingml/2006/main">
               <a:ext uri="{FF2B5EF4-FFF2-40B4-BE49-F238E27FC236}">
-                <a16:creationId xmlns:a16="http://schemas.microsoft.com/office/drawing/2014/main" id="{57B54DDE-6141-4CBF-9694-0BDC49AC111D}"/>
+                <a16:creationId xmlns:a16="http://schemas.microsoft.com/office/drawing/2014/main" id="{2F4B83F5-CBC6-4C60-A899-DD64D1C2B575}"/>
               </a:ext>
             </a:extLst>
           </p:cNvPr>
@@ -11772,10 +11912,10 @@
       </p:sp>
       <p:sp>
         <p:nvSpPr>
-          <p:cNvPr id="8" name="journey-03-number">
+          <p:cNvPr id="9" name="journey-03-number">
             <a:extLst xmlns:a="http://schemas.openxmlformats.org/drawingml/2006/main">
               <a:ext uri="{FF2B5EF4-FFF2-40B4-BE49-F238E27FC236}">
-                <a16:creationId xmlns:a16="http://schemas.microsoft.com/office/drawing/2014/main" id="{1F34097D-F3D2-40B9-BEDA-0D47601F4950}"/>
+                <a16:creationId xmlns:a16="http://schemas.microsoft.com/office/drawing/2014/main" id="{1DBC8D65-9EA2-4794-B598-FBD2C4C80DAA}"/>
               </a:ext>
             </a:extLst>
           </p:cNvPr>
@@ -11931,10 +12071,10 @@
       </p:sp>
       <p:sp>
         <p:nvSpPr>
-          <p:cNvPr id="9" name="journey-03-label">
+          <p:cNvPr id="10" name="journey-03-label">
             <a:extLst xmlns:a="http://schemas.openxmlformats.org/drawingml/2006/main">
               <a:ext uri="{FF2B5EF4-FFF2-40B4-BE49-F238E27FC236}">
-                <a16:creationId xmlns:a16="http://schemas.microsoft.com/office/drawing/2014/main" id="{83DEC27E-AEB3-4BF1-8CDD-E71042D51E57}"/>
+                <a16:creationId xmlns:a16="http://schemas.microsoft.com/office/drawing/2014/main" id="{57B0962A-7C33-40A0-920C-CA6356BE6515}"/>
               </a:ext>
             </a:extLst>
           </p:cNvPr>
@@ -12090,10 +12230,10 @@
       </p:sp>
       <p:sp>
         <p:nvSpPr>
-          <p:cNvPr id="10" name="journey-04-number">
+          <p:cNvPr id="11" name="journey-04-number">
             <a:extLst xmlns:a="http://schemas.openxmlformats.org/drawingml/2006/main">
               <a:ext uri="{FF2B5EF4-FFF2-40B4-BE49-F238E27FC236}">
-                <a16:creationId xmlns:a16="http://schemas.microsoft.com/office/drawing/2014/main" id="{942EABBB-D585-44DD-844E-836ACA77ED07}"/>
+                <a16:creationId xmlns:a16="http://schemas.microsoft.com/office/drawing/2014/main" id="{7C56B208-653F-404D-BED1-5D4D9E04E499}"/>
               </a:ext>
             </a:extLst>
           </p:cNvPr>
@@ -12249,10 +12389,10 @@
       </p:sp>
       <p:sp>
         <p:nvSpPr>
-          <p:cNvPr id="11" name="journey-04-label">
+          <p:cNvPr id="12" name="journey-04-label">
             <a:extLst xmlns:a="http://schemas.openxmlformats.org/drawingml/2006/main">
               <a:ext uri="{FF2B5EF4-FFF2-40B4-BE49-F238E27FC236}">
-                <a16:creationId xmlns:a16="http://schemas.microsoft.com/office/drawing/2014/main" id="{B1DF38E0-C8B9-4FFB-AB01-90D49009A4EC}"/>
+                <a16:creationId xmlns:a16="http://schemas.microsoft.com/office/drawing/2014/main" id="{62E7D626-F54A-4807-A4B5-82A6F5D8048B}"/>
               </a:ext>
             </a:extLst>
           </p:cNvPr>
@@ -12401,17 +12541,17 @@
                 <a:ea typeface="Arial"/>
                 <a:cs typeface="Arial"/>
               </a:rPr>
-              <a:t>Consulta el resultado</a:t>
+              <a:t>Consulta el estado</a:t>
             </a:r>
           </a:p>
         </p:txBody>
       </p:sp>
       <p:sp>
         <p:nvSpPr>
-          <p:cNvPr id="12" name="journey-05-number">
+          <p:cNvPr id="13" name="journey-05-number">
             <a:extLst xmlns:a="http://schemas.openxmlformats.org/drawingml/2006/main">
               <a:ext uri="{FF2B5EF4-FFF2-40B4-BE49-F238E27FC236}">
-                <a16:creationId xmlns:a16="http://schemas.microsoft.com/office/drawing/2014/main" id="{F5562836-AF46-4702-88D4-AAFE40EAB704}"/>
+                <a16:creationId xmlns:a16="http://schemas.microsoft.com/office/drawing/2014/main" id="{6EDBDD3D-CEA7-4592-8E0A-E205CC169065}"/>
               </a:ext>
             </a:extLst>
           </p:cNvPr>
@@ -12567,10 +12707,10 @@
       </p:sp>
       <p:sp>
         <p:nvSpPr>
-          <p:cNvPr id="13" name="journey-05-label">
+          <p:cNvPr id="14" name="journey-05-label">
             <a:extLst xmlns:a="http://schemas.openxmlformats.org/drawingml/2006/main">
               <a:ext uri="{FF2B5EF4-FFF2-40B4-BE49-F238E27FC236}">
-                <a16:creationId xmlns:a16="http://schemas.microsoft.com/office/drawing/2014/main" id="{6AE931C5-2499-42EF-8213-35E142F2896B}"/>
+                <a16:creationId xmlns:a16="http://schemas.microsoft.com/office/drawing/2014/main" id="{672F9DBA-B072-4B18-853E-1182A6BAA73E}"/>
               </a:ext>
             </a:extLst>
           </p:cNvPr>
@@ -12719,17 +12859,17 @@
                 <a:ea typeface="Arial"/>
                 <a:cs typeface="Arial"/>
               </a:rPr>
-              <a:t>Revisa pagos y avisos</a:t>
+              <a:t>Revisa depósitos y avisos</a:t>
             </a:r>
           </a:p>
         </p:txBody>
       </p:sp>
       <p:sp>
         <p:nvSpPr>
-          <p:cNvPr id="14" name="journey-promise">
+          <p:cNvPr id="15" name="journey-promise">
             <a:extLst xmlns:a="http://schemas.openxmlformats.org/drawingml/2006/main">
               <a:ext uri="{FF2B5EF4-FFF2-40B4-BE49-F238E27FC236}">
-                <a16:creationId xmlns:a16="http://schemas.microsoft.com/office/drawing/2014/main" id="{7AEE5C82-BEB7-4AFE-B89C-675B595FFB5E}"/>
+                <a16:creationId xmlns:a16="http://schemas.microsoft.com/office/drawing/2014/main" id="{39542AC2-7DE9-43B1-AAC0-56BBCFD604A5}"/>
               </a:ext>
             </a:extLst>
           </p:cNvPr>
@@ -12740,8 +12880,8 @@
         </p:nvSpPr>
         <p:spPr>
           <a:xfrm xmlns:a="http://schemas.openxmlformats.org/drawingml/2006/main">
-            <a:off x="7000875" y="2657475"/>
-            <a:ext cx="4191000" cy="1381125"/>
+            <a:off x="742950" y="5810250"/>
+            <a:ext cx="6667500" cy="333375"/>
           </a:xfrm>
           <a:prstGeom xmlns:a="http://schemas.openxmlformats.org/drawingml/2006/main" prst="rect">
             <a:avLst/>
@@ -12753,12 +12893,12 @@
           </a:ln>
         </p:spPr>
         <p:txBody>
-          <a:bodyPr xmlns:a="http://schemas.openxmlformats.org/drawingml/2006/main" wrap="square" lIns="0" tIns="0" rIns="0" bIns="0" anchor="t">
+          <a:bodyPr xmlns:a="http://schemas.openxmlformats.org/drawingml/2006/main" wrap="square" lIns="0" tIns="0" rIns="0" bIns="0" anchor="ctr">
             <a:normAutofit fontScale="100000"/>
           </a:bodyPr>
           <a:lstStyle xmlns:a="http://schemas.openxmlformats.org/drawingml/2006/main">
             <a:defPPr algn="l">
-              <a:defRPr sz="2700" b="1">
+              <a:defRPr sz="1650" b="1">
                 <a:solidFill>
                   <a:srgbClr val="092754"/>
                 </a:solidFill>
@@ -12768,7 +12908,7 @@
               </a:defRPr>
             </a:defPPr>
             <a:lvl1pPr algn="l">
-              <a:defRPr sz="2700" b="1">
+              <a:defRPr sz="1650" b="1">
                 <a:solidFill>
                   <a:srgbClr val="092754"/>
                 </a:solidFill>
@@ -12778,7 +12918,7 @@
               </a:defRPr>
             </a:lvl1pPr>
             <a:lvl2pPr algn="l">
-              <a:defRPr sz="2700" b="1">
+              <a:defRPr sz="1650" b="1">
                 <a:solidFill>
                   <a:srgbClr val="092754"/>
                 </a:solidFill>
@@ -12788,7 +12928,7 @@
               </a:defRPr>
             </a:lvl2pPr>
             <a:lvl3pPr algn="l">
-              <a:defRPr sz="2700" b="1">
+              <a:defRPr sz="1650" b="1">
                 <a:solidFill>
                   <a:srgbClr val="092754"/>
                 </a:solidFill>
@@ -12798,7 +12938,7 @@
               </a:defRPr>
             </a:lvl3pPr>
             <a:lvl4pPr algn="l">
-              <a:defRPr sz="2700" b="1">
+              <a:defRPr sz="1650" b="1">
                 <a:solidFill>
                   <a:srgbClr val="092754"/>
                 </a:solidFill>
@@ -12808,7 +12948,7 @@
               </a:defRPr>
             </a:lvl4pPr>
             <a:lvl5pPr algn="l">
-              <a:defRPr sz="2700" b="1">
+              <a:defRPr sz="1650" b="1">
                 <a:solidFill>
                   <a:srgbClr val="092754"/>
                 </a:solidFill>
@@ -12818,7 +12958,7 @@
               </a:defRPr>
             </a:lvl5pPr>
             <a:lvl6pPr algn="l">
-              <a:defRPr sz="2700" b="1">
+              <a:defRPr sz="1650" b="1">
                 <a:solidFill>
                   <a:srgbClr val="092754"/>
                 </a:solidFill>
@@ -12828,7 +12968,7 @@
               </a:defRPr>
             </a:lvl6pPr>
             <a:lvl7pPr algn="l">
-              <a:defRPr sz="2700" b="1">
+              <a:defRPr sz="1650" b="1">
                 <a:solidFill>
                   <a:srgbClr val="092754"/>
                 </a:solidFill>
@@ -12838,7 +12978,7 @@
               </a:defRPr>
             </a:lvl7pPr>
             <a:lvl8pPr algn="l">
-              <a:defRPr sz="2700" b="1">
+              <a:defRPr sz="1650" b="1">
                 <a:solidFill>
                   <a:srgbClr val="092754"/>
                 </a:solidFill>
@@ -12848,7 +12988,7 @@
               </a:defRPr>
             </a:lvl8pPr>
             <a:lvl9pPr algn="l">
-              <a:defRPr sz="2700" b="1">
+              <a:defRPr sz="1650" b="1">
                 <a:solidFill>
                   <a:srgbClr val="092754"/>
                 </a:solidFill>
@@ -12860,11 +13000,7 @@
           </a:lstStyle>
           <a:p xmlns:a="http://schemas.openxmlformats.org/drawingml/2006/main">
             <a:pPr algn="l">
-              <a:lnSpc>
-                <a:spcPct val="106000"/>
-              </a:lnSpc>
-              <a:buNone/>
-              <a:defRPr sz="2700" b="1">
+              <a:defRPr sz="1650" b="1">
                 <a:solidFill>
                   <a:srgbClr val="092754"/>
                 </a:solidFill>
@@ -12874,7 +13010,7 @@
               </a:defRPr>
             </a:pPr>
             <a:r>
-              <a:rPr sz="2700" b="1">
+              <a:rPr sz="1650" b="1">
                 <a:solidFill>
                   <a:srgbClr val="092754"/>
                 </a:solidFill>
@@ -12882,178 +13018,43 @@
                 <a:ea typeface="Arial"/>
                 <a:cs typeface="Arial"/>
               </a:rPr>
-              <a:t>Cada cuenta muestra la información de su propio estudiante.</a:t>
+              <a:t>Información privada de cada cuenta.</a:t>
             </a:r>
           </a:p>
         </p:txBody>
       </p:sp>
-      <p:sp>
-        <p:nvSpPr>
-          <p:cNvPr id="15" name="journey-detail">
+      <p:pic>
+        <p:nvPicPr>
+          <p:cNvPr id="16" name="">
             <a:extLst xmlns:a="http://schemas.openxmlformats.org/drawingml/2006/main">
               <a:ext uri="{FF2B5EF4-FFF2-40B4-BE49-F238E27FC236}">
-                <a16:creationId xmlns:a16="http://schemas.microsoft.com/office/drawing/2014/main" id="{4A0948EA-DE45-4663-9346-0339A63CA52A}"/>
+                <a16:creationId xmlns:a16="http://schemas.microsoft.com/office/drawing/2014/main" id="{B3D62D46-7902-4061-900E-B19CFAF2027F}"/>
               </a:ext>
             </a:extLst>
           </p:cNvPr>
-          <p:cNvSpPr>
-            <a:spLocks xmlns:a="http://schemas.openxmlformats.org/drawingml/2006/main" noGrp="1"/>
-          </p:cNvSpPr>
+          <p:cNvPicPr>
+            <a:picLocks xmlns:a="http://schemas.openxmlformats.org/drawingml/2006/main" noChangeAspect="1"/>
+          </p:cNvPicPr>
           <p:nvPr/>
-        </p:nvSpPr>
+        </p:nvPicPr>
+        <p:blipFill>
+          <a:blip xmlns:r="http://schemas.openxmlformats.org/officeDocument/2006/relationships" xmlns:a="http://schemas.openxmlformats.org/drawingml/2006/main" r:embed="Rad5ef0d617d743e4"/>
+          <a:stretch xmlns:a="http://schemas.openxmlformats.org/drawingml/2006/main"/>
+        </p:blipFill>
         <p:spPr>
           <a:xfrm xmlns:a="http://schemas.openxmlformats.org/drawingml/2006/main">
-            <a:off x="7000875" y="4276725"/>
-            <a:ext cx="4000500" cy="904875"/>
+            <a:off x="8257972" y="1409700"/>
+            <a:ext cx="2200681" cy="4762500"/>
           </a:xfrm>
           <a:prstGeom xmlns:a="http://schemas.openxmlformats.org/drawingml/2006/main" prst="rect">
             <a:avLst/>
           </a:prstGeom>
-          <a:noFill xmlns:a="http://schemas.openxmlformats.org/drawingml/2006/main"/>
-          <a:ln xmlns:a="http://schemas.openxmlformats.org/drawingml/2006/main" w="0">
-            <a:noFill/>
-            <a:prstDash val="solid"/>
-          </a:ln>
         </p:spPr>
-        <p:txBody>
-          <a:bodyPr xmlns:a="http://schemas.openxmlformats.org/drawingml/2006/main" wrap="square" lIns="0" tIns="0" rIns="0" bIns="0" anchor="t">
-            <a:normAutofit fontScale="100000"/>
-          </a:bodyPr>
-          <a:lstStyle xmlns:a="http://schemas.openxmlformats.org/drawingml/2006/main">
-            <a:defPPr algn="l">
-              <a:defRPr sz="1725">
-                <a:solidFill>
-                  <a:srgbClr val="60748A"/>
-                </a:solidFill>
-                <a:latin typeface="Arial"/>
-                <a:ea typeface="Arial"/>
-                <a:cs typeface="Arial"/>
-              </a:defRPr>
-            </a:defPPr>
-            <a:lvl1pPr algn="l">
-              <a:defRPr sz="1725">
-                <a:solidFill>
-                  <a:srgbClr val="60748A"/>
-                </a:solidFill>
-                <a:latin typeface="Arial"/>
-                <a:ea typeface="Arial"/>
-                <a:cs typeface="Arial"/>
-              </a:defRPr>
-            </a:lvl1pPr>
-            <a:lvl2pPr algn="l">
-              <a:defRPr sz="1725">
-                <a:solidFill>
-                  <a:srgbClr val="60748A"/>
-                </a:solidFill>
-                <a:latin typeface="Arial"/>
-                <a:ea typeface="Arial"/>
-                <a:cs typeface="Arial"/>
-              </a:defRPr>
-            </a:lvl2pPr>
-            <a:lvl3pPr algn="l">
-              <a:defRPr sz="1725">
-                <a:solidFill>
-                  <a:srgbClr val="60748A"/>
-                </a:solidFill>
-                <a:latin typeface="Arial"/>
-                <a:ea typeface="Arial"/>
-                <a:cs typeface="Arial"/>
-              </a:defRPr>
-            </a:lvl3pPr>
-            <a:lvl4pPr algn="l">
-              <a:defRPr sz="1725">
-                <a:solidFill>
-                  <a:srgbClr val="60748A"/>
-                </a:solidFill>
-                <a:latin typeface="Arial"/>
-                <a:ea typeface="Arial"/>
-                <a:cs typeface="Arial"/>
-              </a:defRPr>
-            </a:lvl4pPr>
-            <a:lvl5pPr algn="l">
-              <a:defRPr sz="1725">
-                <a:solidFill>
-                  <a:srgbClr val="60748A"/>
-                </a:solidFill>
-                <a:latin typeface="Arial"/>
-                <a:ea typeface="Arial"/>
-                <a:cs typeface="Arial"/>
-              </a:defRPr>
-            </a:lvl5pPr>
-            <a:lvl6pPr algn="l">
-              <a:defRPr sz="1725">
-                <a:solidFill>
-                  <a:srgbClr val="60748A"/>
-                </a:solidFill>
-                <a:latin typeface="Arial"/>
-                <a:ea typeface="Arial"/>
-                <a:cs typeface="Arial"/>
-              </a:defRPr>
-            </a:lvl6pPr>
-            <a:lvl7pPr algn="l">
-              <a:defRPr sz="1725">
-                <a:solidFill>
-                  <a:srgbClr val="60748A"/>
-                </a:solidFill>
-                <a:latin typeface="Arial"/>
-                <a:ea typeface="Arial"/>
-                <a:cs typeface="Arial"/>
-              </a:defRPr>
-            </a:lvl7pPr>
-            <a:lvl8pPr algn="l">
-              <a:defRPr sz="1725">
-                <a:solidFill>
-                  <a:srgbClr val="60748A"/>
-                </a:solidFill>
-                <a:latin typeface="Arial"/>
-                <a:ea typeface="Arial"/>
-                <a:cs typeface="Arial"/>
-              </a:defRPr>
-            </a:lvl8pPr>
-            <a:lvl9pPr algn="l">
-              <a:defRPr sz="1725">
-                <a:solidFill>
-                  <a:srgbClr val="60748A"/>
-                </a:solidFill>
-                <a:latin typeface="Arial"/>
-                <a:ea typeface="Arial"/>
-                <a:cs typeface="Arial"/>
-              </a:defRPr>
-            </a:lvl9pPr>
-          </a:lstStyle>
-          <a:p xmlns:a="http://schemas.openxmlformats.org/drawingml/2006/main">
-            <a:pPr algn="l">
-              <a:lnSpc>
-                <a:spcPct val="110000"/>
-              </a:lnSpc>
-              <a:buNone/>
-              <a:defRPr sz="1725">
-                <a:solidFill>
-                  <a:srgbClr val="60748A"/>
-                </a:solidFill>
-                <a:latin typeface="Arial"/>
-                <a:ea typeface="Arial"/>
-                <a:cs typeface="Arial"/>
-              </a:defRPr>
-            </a:pPr>
-            <a:r>
-              <a:rPr sz="1725">
-                <a:solidFill>
-                  <a:srgbClr val="60748A"/>
-                </a:solidFill>
-                <a:latin typeface="Arial"/>
-                <a:ea typeface="Arial"/>
-                <a:cs typeface="Arial"/>
-              </a:rPr>
-              <a:t>El portal presenta convocatorias, solicitudes, depósitos registrados, noticias y notificaciones.</a:t>
-            </a:r>
-          </a:p>
-        </p:txBody>
-      </p:sp>
+      </p:pic>
     </p:spTree>
     <p:extLst>
       <p:ext uri="{BB962C8B-B14F-4D97-AF65-F5344CB8AC3E}">
-        <p14:creationId xmlns:p14="http://schemas.microsoft.com/office/powerpoint/2010/main" val="1407855368"/>
+        <p14:creationId xmlns:p14="http://schemas.microsoft.com/office/powerpoint/2010/main" val="544881108"/>
       </p:ext>
     </p:extLst>
   </p:cSld>
@@ -13079,12 +13080,40 @@
       <p:grpSpPr>
         <a:xfrm xmlns:a="http://schemas.openxmlformats.org/drawingml/2006/main"/>
       </p:grpSpPr>
+      <p:pic>
+        <p:nvPicPr>
+          <p:cNvPr id="14" name="">
+            <a:extLst xmlns:a="http://schemas.openxmlformats.org/drawingml/2006/main">
+              <a:ext uri="{FF2B5EF4-FFF2-40B4-BE49-F238E27FC236}">
+                <a16:creationId xmlns:a16="http://schemas.microsoft.com/office/drawing/2014/main" id="{8F580754-85F4-418F-B7BD-63A4C0A0A07C}"/>
+              </a:ext>
+            </a:extLst>
+          </p:cNvPr>
+          <p:cNvPicPr>
+            <a:picLocks xmlns:a="http://schemas.openxmlformats.org/drawingml/2006/main" noChangeAspect="1"/>
+          </p:cNvPicPr>
+          <p:nvPr/>
+        </p:nvPicPr>
+        <p:blipFill>
+          <a:blip xmlns:r="http://schemas.openxmlformats.org/officeDocument/2006/relationships" xmlns:a="http://schemas.openxmlformats.org/drawingml/2006/main" r:embed="Rb3a0c78ebab641fb"/>
+          <a:stretch xmlns:a="http://schemas.openxmlformats.org/drawingml/2006/main"/>
+        </p:blipFill>
+        <p:spPr>
+          <a:xfrm xmlns:a="http://schemas.openxmlformats.org/drawingml/2006/main">
+            <a:off x="11096625" y="171450"/>
+            <a:ext cx="381000" cy="381000"/>
+          </a:xfrm>
+          <a:prstGeom xmlns:a="http://schemas.openxmlformats.org/drawingml/2006/main" prst="rect">
+            <a:avLst/>
+          </a:prstGeom>
+        </p:spPr>
+      </p:pic>
       <p:sp>
         <p:nvSpPr>
-          <p:cNvPr id="13" name="footer-6">
+          <p:cNvPr id="2" name="footer-6">
             <a:extLst xmlns:a="http://schemas.openxmlformats.org/drawingml/2006/main">
               <a:ext uri="{FF2B5EF4-FFF2-40B4-BE49-F238E27FC236}">
-                <a16:creationId xmlns:a16="http://schemas.microsoft.com/office/drawing/2014/main" id="{BEEE50C1-7C30-4463-972E-59C83ECF45C2}"/>
+                <a16:creationId xmlns:a16="http://schemas.microsoft.com/office/drawing/2014/main" id="{D05F050C-8B14-4494-B44E-A4BFA41FBF15}"/>
               </a:ext>
             </a:extLst>
           </p:cNvPr>
@@ -13240,10 +13269,10 @@
       </p:sp>
       <p:sp>
         <p:nvSpPr>
-          <p:cNvPr id="2" name="slide-title">
+          <p:cNvPr id="3" name="slide-title">
             <a:extLst xmlns:a="http://schemas.openxmlformats.org/drawingml/2006/main">
               <a:ext uri="{FF2B5EF4-FFF2-40B4-BE49-F238E27FC236}">
-                <a16:creationId xmlns:a16="http://schemas.microsoft.com/office/drawing/2014/main" id="{48A0C482-9E78-4A60-B749-7F65D57BE77C}"/>
+                <a16:creationId xmlns:a16="http://schemas.microsoft.com/office/drawing/2014/main" id="{2EB742F4-C5B8-4270-879B-2C8A5DF174AD}"/>
               </a:ext>
             </a:extLst>
           </p:cNvPr>
@@ -13399,10 +13428,10 @@
       </p:sp>
       <p:sp>
         <p:nvSpPr>
-          <p:cNvPr id="3" name="admin-intro">
+          <p:cNvPr id="4" name="admin-intro">
             <a:extLst xmlns:a="http://schemas.openxmlformats.org/drawingml/2006/main">
               <a:ext uri="{FF2B5EF4-FFF2-40B4-BE49-F238E27FC236}">
-                <a16:creationId xmlns:a16="http://schemas.microsoft.com/office/drawing/2014/main" id="{7B32F7AE-C9AE-4E43-98F3-C8EE21A5F94F}"/>
+                <a16:creationId xmlns:a16="http://schemas.microsoft.com/office/drawing/2014/main" id="{2443DC55-F917-42F3-8790-DCB772D5E8C0}"/>
               </a:ext>
             </a:extLst>
           </p:cNvPr>
@@ -13551,17 +13580,17 @@
                 <a:ea typeface="Arial"/>
                 <a:cs typeface="Arial"/>
               </a:rPr>
-              <a:t>El personal gestiona los módulos desde la aplicación web y Windows Forms</a:t>
+              <a:t>El personal trabaja desde el panel web o el ejecutable de Windows Forms</a:t>
             </a:r>
           </a:p>
         </p:txBody>
       </p:sp>
       <p:sp>
         <p:nvSpPr>
-          <p:cNvPr id="4" name="crud-Listar-title">
+          <p:cNvPr id="5" name="crud-Listar-title">
             <a:extLst xmlns:a="http://schemas.openxmlformats.org/drawingml/2006/main">
               <a:ext uri="{FF2B5EF4-FFF2-40B4-BE49-F238E27FC236}">
-                <a16:creationId xmlns:a16="http://schemas.microsoft.com/office/drawing/2014/main" id="{9F0F7415-B807-443B-954F-8CC7D242CD90}"/>
+                <a16:creationId xmlns:a16="http://schemas.microsoft.com/office/drawing/2014/main" id="{CD0E0580-1D86-4C6B-909F-EC1C5F360D46}"/>
               </a:ext>
             </a:extLst>
           </p:cNvPr>
@@ -13717,10 +13746,10 @@
       </p:sp>
       <p:sp>
         <p:nvSpPr>
-          <p:cNvPr id="5" name="crud-Listar-description">
+          <p:cNvPr id="6" name="crud-Listar-description">
             <a:extLst xmlns:a="http://schemas.openxmlformats.org/drawingml/2006/main">
               <a:ext uri="{FF2B5EF4-FFF2-40B4-BE49-F238E27FC236}">
-                <a16:creationId xmlns:a16="http://schemas.microsoft.com/office/drawing/2014/main" id="{509E30E4-3B0D-4BBE-802E-099A65E4F6D5}"/>
+                <a16:creationId xmlns:a16="http://schemas.microsoft.com/office/drawing/2014/main" id="{7BB1827D-423F-45F6-AA5C-A51DF6EB6864}"/>
               </a:ext>
             </a:extLst>
           </p:cNvPr>
@@ -13880,10 +13909,10 @@
       </p:sp>
       <p:sp>
         <p:nvSpPr>
-          <p:cNvPr id="6" name="crud-Crear-title">
+          <p:cNvPr id="7" name="crud-Crear-title">
             <a:extLst xmlns:a="http://schemas.openxmlformats.org/drawingml/2006/main">
               <a:ext uri="{FF2B5EF4-FFF2-40B4-BE49-F238E27FC236}">
-                <a16:creationId xmlns:a16="http://schemas.microsoft.com/office/drawing/2014/main" id="{B2DEF40D-F171-465B-A307-B15379518601}"/>
+                <a16:creationId xmlns:a16="http://schemas.microsoft.com/office/drawing/2014/main" id="{8F16BA2C-0E33-4232-8272-9D418CE51AF3}"/>
               </a:ext>
             </a:extLst>
           </p:cNvPr>
@@ -14039,10 +14068,10 @@
       </p:sp>
       <p:sp>
         <p:nvSpPr>
-          <p:cNvPr id="7" name="crud-Crear-description">
+          <p:cNvPr id="8" name="crud-Crear-description">
             <a:extLst xmlns:a="http://schemas.openxmlformats.org/drawingml/2006/main">
               <a:ext uri="{FF2B5EF4-FFF2-40B4-BE49-F238E27FC236}">
-                <a16:creationId xmlns:a16="http://schemas.microsoft.com/office/drawing/2014/main" id="{493BC757-72ED-49F1-95EC-C4F006BA0B59}"/>
+                <a16:creationId xmlns:a16="http://schemas.microsoft.com/office/drawing/2014/main" id="{9CD112F1-1389-4CE9-9D88-433B9B08C160}"/>
               </a:ext>
             </a:extLst>
           </p:cNvPr>
@@ -14202,10 +14231,10 @@
       </p:sp>
       <p:sp>
         <p:nvSpPr>
-          <p:cNvPr id="8" name="crud-Editar-title">
+          <p:cNvPr id="9" name="crud-Editar-title">
             <a:extLst xmlns:a="http://schemas.openxmlformats.org/drawingml/2006/main">
               <a:ext uri="{FF2B5EF4-FFF2-40B4-BE49-F238E27FC236}">
-                <a16:creationId xmlns:a16="http://schemas.microsoft.com/office/drawing/2014/main" id="{5ACC386C-96A7-4AF0-92A4-CE565505CA09}"/>
+                <a16:creationId xmlns:a16="http://schemas.microsoft.com/office/drawing/2014/main" id="{F39BCD23-78E4-41B0-8CA0-1B20A171E0D7}"/>
               </a:ext>
             </a:extLst>
           </p:cNvPr>
@@ -14361,10 +14390,10 @@
       </p:sp>
       <p:sp>
         <p:nvSpPr>
-          <p:cNvPr id="9" name="crud-Editar-description">
+          <p:cNvPr id="10" name="crud-Editar-description">
             <a:extLst xmlns:a="http://schemas.openxmlformats.org/drawingml/2006/main">
               <a:ext uri="{FF2B5EF4-FFF2-40B4-BE49-F238E27FC236}">
-                <a16:creationId xmlns:a16="http://schemas.microsoft.com/office/drawing/2014/main" id="{F4D51541-A002-4111-9457-F8C41CF56A66}"/>
+                <a16:creationId xmlns:a16="http://schemas.microsoft.com/office/drawing/2014/main" id="{3E18C002-E590-4DB9-87A4-AC65BBCC81EC}"/>
               </a:ext>
             </a:extLst>
           </p:cNvPr>
@@ -14524,10 +14553,10 @@
       </p:sp>
       <p:sp>
         <p:nvSpPr>
-          <p:cNvPr id="10" name="crud-Eliminar-title">
+          <p:cNvPr id="11" name="crud-Eliminar-title">
             <a:extLst xmlns:a="http://schemas.openxmlformats.org/drawingml/2006/main">
               <a:ext uri="{FF2B5EF4-FFF2-40B4-BE49-F238E27FC236}">
-                <a16:creationId xmlns:a16="http://schemas.microsoft.com/office/drawing/2014/main" id="{D7179B31-A425-48DC-9B2C-FD60E794B019}"/>
+                <a16:creationId xmlns:a16="http://schemas.microsoft.com/office/drawing/2014/main" id="{517AF500-320D-4880-AD7D-1591BD87E4CD}"/>
               </a:ext>
             </a:extLst>
           </p:cNvPr>
@@ -14683,10 +14712,10 @@
       </p:sp>
       <p:sp>
         <p:nvSpPr>
-          <p:cNvPr id="11" name="crud-Eliminar-description">
+          <p:cNvPr id="12" name="crud-Eliminar-description">
             <a:extLst xmlns:a="http://schemas.openxmlformats.org/drawingml/2006/main">
               <a:ext uri="{FF2B5EF4-FFF2-40B4-BE49-F238E27FC236}">
-                <a16:creationId xmlns:a16="http://schemas.microsoft.com/office/drawing/2014/main" id="{53C89421-8736-4A1B-B4E0-63E865A7A170}"/>
+                <a16:creationId xmlns:a16="http://schemas.microsoft.com/office/drawing/2014/main" id="{C115756F-0185-4780-A84C-4A6E070B3FA8}"/>
               </a:ext>
             </a:extLst>
           </p:cNvPr>
@@ -14846,10 +14875,10 @@
       </p:sp>
       <p:sp>
         <p:nvSpPr>
-          <p:cNvPr id="12" name="admin-rule">
+          <p:cNvPr id="13" name="admin-rule">
             <a:extLst xmlns:a="http://schemas.openxmlformats.org/drawingml/2006/main">
               <a:ext uri="{FF2B5EF4-FFF2-40B4-BE49-F238E27FC236}">
-                <a16:creationId xmlns:a16="http://schemas.microsoft.com/office/drawing/2014/main" id="{65254263-B036-4F3F-A0C7-8E5851029A51}"/>
+                <a16:creationId xmlns:a16="http://schemas.microsoft.com/office/drawing/2014/main" id="{9CEB274F-B0F7-4ACB-8DF3-90687DC35460}"/>
               </a:ext>
             </a:extLst>
           </p:cNvPr>
@@ -14998,7 +15027,7 @@
                 <a:ea typeface="Arial"/>
                 <a:cs typeface="Arial"/>
               </a:rPr>
-              <a:t>El sistema valida los datos y protege registros relacionados.</a:t>
+              <a:t>Los registros nuevos se revisan en Registros pendientes antes de activar la cuenta.</a:t>
             </a:r>
           </a:p>
         </p:txBody>
@@ -15006,7 +15035,7 @@
     </p:spTree>
     <p:extLst>
       <p:ext uri="{BB962C8B-B14F-4D97-AF65-F5344CB8AC3E}">
-        <p14:creationId xmlns:p14="http://schemas.microsoft.com/office/powerpoint/2010/main" val="436573475"/>
+        <p14:creationId xmlns:p14="http://schemas.microsoft.com/office/powerpoint/2010/main" val="819583156"/>
       </p:ext>
     </p:extLst>
   </p:cSld>
@@ -15032,12 +15061,40 @@
       <p:grpSpPr>
         <a:xfrm xmlns:a="http://schemas.openxmlformats.org/drawingml/2006/main"/>
       </p:grpSpPr>
+      <p:pic>
+        <p:nvPicPr>
+          <p:cNvPr id="10" name="">
+            <a:extLst xmlns:a="http://schemas.openxmlformats.org/drawingml/2006/main">
+              <a:ext uri="{FF2B5EF4-FFF2-40B4-BE49-F238E27FC236}">
+                <a16:creationId xmlns:a16="http://schemas.microsoft.com/office/drawing/2014/main" id="{283698AB-E561-4AE2-AE8F-F1F6B4AB3E68}"/>
+              </a:ext>
+            </a:extLst>
+          </p:cNvPr>
+          <p:cNvPicPr>
+            <a:picLocks xmlns:a="http://schemas.openxmlformats.org/drawingml/2006/main" noChangeAspect="1"/>
+          </p:cNvPicPr>
+          <p:nvPr/>
+        </p:nvPicPr>
+        <p:blipFill>
+          <a:blip xmlns:r="http://schemas.openxmlformats.org/officeDocument/2006/relationships" xmlns:a="http://schemas.openxmlformats.org/drawingml/2006/main" r:embed="R8308e2a9da5c4186"/>
+          <a:stretch xmlns:a="http://schemas.openxmlformats.org/drawingml/2006/main"/>
+        </p:blipFill>
+        <p:spPr>
+          <a:xfrm xmlns:a="http://schemas.openxmlformats.org/drawingml/2006/main">
+            <a:off x="11096625" y="171450"/>
+            <a:ext cx="381000" cy="381000"/>
+          </a:xfrm>
+          <a:prstGeom xmlns:a="http://schemas.openxmlformats.org/drawingml/2006/main" prst="rect">
+            <a:avLst/>
+          </a:prstGeom>
+        </p:spPr>
+      </p:pic>
       <p:sp>
         <p:nvSpPr>
-          <p:cNvPr id="9" name="footer-7">
+          <p:cNvPr id="2" name="footer-7">
             <a:extLst xmlns:a="http://schemas.openxmlformats.org/drawingml/2006/main">
               <a:ext uri="{FF2B5EF4-FFF2-40B4-BE49-F238E27FC236}">
-                <a16:creationId xmlns:a16="http://schemas.microsoft.com/office/drawing/2014/main" id="{1D7C5E5C-64BA-4DF3-B315-662083DE5190}"/>
+                <a16:creationId xmlns:a16="http://schemas.microsoft.com/office/drawing/2014/main" id="{FFB9EAB2-7E08-4087-A6F1-90BC1F97AF47}"/>
               </a:ext>
             </a:extLst>
           </p:cNvPr>
@@ -15193,10 +15250,10 @@
       </p:sp>
       <p:sp>
         <p:nvSpPr>
-          <p:cNvPr id="2" name="slide-title">
+          <p:cNvPr id="3" name="slide-title">
             <a:extLst xmlns:a="http://schemas.openxmlformats.org/drawingml/2006/main">
               <a:ext uri="{FF2B5EF4-FFF2-40B4-BE49-F238E27FC236}">
-                <a16:creationId xmlns:a16="http://schemas.microsoft.com/office/drawing/2014/main" id="{6A153B51-54FD-4942-B67A-C9A8E4BD625D}"/>
+                <a16:creationId xmlns:a16="http://schemas.microsoft.com/office/drawing/2014/main" id="{DA4D2EC9-706F-420A-A667-AAC16256B38C}"/>
               </a:ext>
             </a:extLst>
           </p:cNvPr>
@@ -15352,10 +15409,10 @@
       </p:sp>
       <p:sp>
         <p:nvSpPr>
-          <p:cNvPr id="3" name="privacy-headline">
+          <p:cNvPr id="4" name="privacy-headline">
             <a:extLst xmlns:a="http://schemas.openxmlformats.org/drawingml/2006/main">
               <a:ext uri="{FF2B5EF4-FFF2-40B4-BE49-F238E27FC236}">
-                <a16:creationId xmlns:a16="http://schemas.microsoft.com/office/drawing/2014/main" id="{705B731D-C3C8-4EC4-8AB5-AB8DF1BF783D}"/>
+                <a16:creationId xmlns:a16="http://schemas.microsoft.com/office/drawing/2014/main" id="{456EB50B-ECD1-4016-9091-DA627D0821EA}"/>
               </a:ext>
             </a:extLst>
           </p:cNvPr>
@@ -15515,10 +15572,10 @@
       </p:sp>
       <p:sp>
         <p:nvSpPr>
-          <p:cNvPr id="4" name="privacy-detail">
+          <p:cNvPr id="5" name="privacy-detail">
             <a:extLst xmlns:a="http://schemas.openxmlformats.org/drawingml/2006/main">
               <a:ext uri="{FF2B5EF4-FFF2-40B4-BE49-F238E27FC236}">
-                <a16:creationId xmlns:a16="http://schemas.microsoft.com/office/drawing/2014/main" id="{DCE03077-BCB3-4330-902B-92DA68F1080E}"/>
+                <a16:creationId xmlns:a16="http://schemas.microsoft.com/office/drawing/2014/main" id="{A3B7FA98-39DA-41AA-8AA6-A9E65E40E1AD}"/>
               </a:ext>
             </a:extLst>
           </p:cNvPr>
@@ -15678,10 +15735,10 @@
       </p:sp>
       <p:sp>
         <p:nvSpPr>
-          <p:cNvPr id="5" name="payments-label">
+          <p:cNvPr id="6" name="payments-label">
             <a:extLst xmlns:a="http://schemas.openxmlformats.org/drawingml/2006/main">
               <a:ext uri="{FF2B5EF4-FFF2-40B4-BE49-F238E27FC236}">
-                <a16:creationId xmlns:a16="http://schemas.microsoft.com/office/drawing/2014/main" id="{A5E5F187-725F-44D5-B8F6-9329BE1894D6}"/>
+                <a16:creationId xmlns:a16="http://schemas.microsoft.com/office/drawing/2014/main" id="{32DE7AF2-FF35-4310-A8B2-B7F8627237D1}"/>
               </a:ext>
             </a:extLst>
           </p:cNvPr>
@@ -15837,10 +15894,10 @@
       </p:sp>
       <p:sp>
         <p:nvSpPr>
-          <p:cNvPr id="6" name="payments-text">
+          <p:cNvPr id="7" name="payments-text">
             <a:extLst xmlns:a="http://schemas.openxmlformats.org/drawingml/2006/main">
               <a:ext uri="{FF2B5EF4-FFF2-40B4-BE49-F238E27FC236}">
-                <a16:creationId xmlns:a16="http://schemas.microsoft.com/office/drawing/2014/main" id="{6988C1CE-D932-4756-8962-A382DEA9B0EC}"/>
+                <a16:creationId xmlns:a16="http://schemas.microsoft.com/office/drawing/2014/main" id="{0015C957-C96D-44CC-BC58-1AE3C7FD5937}"/>
               </a:ext>
             </a:extLst>
           </p:cNvPr>
@@ -15996,10 +16053,10 @@
       </p:sp>
       <p:sp>
         <p:nvSpPr>
-          <p:cNvPr id="7" name="transfers-label">
+          <p:cNvPr id="8" name="transfers-label">
             <a:extLst xmlns:a="http://schemas.openxmlformats.org/drawingml/2006/main">
               <a:ext uri="{FF2B5EF4-FFF2-40B4-BE49-F238E27FC236}">
-                <a16:creationId xmlns:a16="http://schemas.microsoft.com/office/drawing/2014/main" id="{80BFD3D6-46BB-45F4-A65A-85F3BD59F2AF}"/>
+                <a16:creationId xmlns:a16="http://schemas.microsoft.com/office/drawing/2014/main" id="{A108FEB9-6913-4F65-9C35-0E73F89E9A08}"/>
               </a:ext>
             </a:extLst>
           </p:cNvPr>
@@ -16155,10 +16212,10 @@
       </p:sp>
       <p:sp>
         <p:nvSpPr>
-          <p:cNvPr id="8" name="transfers-text">
+          <p:cNvPr id="9" name="transfers-text">
             <a:extLst xmlns:a="http://schemas.openxmlformats.org/drawingml/2006/main">
               <a:ext uri="{FF2B5EF4-FFF2-40B4-BE49-F238E27FC236}">
-                <a16:creationId xmlns:a16="http://schemas.microsoft.com/office/drawing/2014/main" id="{3E5A2AA1-3DBD-444F-B257-B99FDDBE7C31}"/>
+                <a16:creationId xmlns:a16="http://schemas.microsoft.com/office/drawing/2014/main" id="{4D02BDC6-C881-470B-891E-07EBF3410F4B}"/>
               </a:ext>
             </a:extLst>
           </p:cNvPr>
@@ -16315,7 +16372,7 @@
     </p:spTree>
     <p:extLst>
       <p:ext uri="{BB962C8B-B14F-4D97-AF65-F5344CB8AC3E}">
-        <p14:creationId xmlns:p14="http://schemas.microsoft.com/office/powerpoint/2010/main" val="1383557174"/>
+        <p14:creationId xmlns:p14="http://schemas.microsoft.com/office/powerpoint/2010/main" val="433166610"/>
       </p:ext>
     </p:extLst>
   </p:cSld>
@@ -16341,12 +16398,40 @@
       <p:grpSpPr>
         <a:xfrm xmlns:a="http://schemas.openxmlformats.org/drawingml/2006/main"/>
       </p:grpSpPr>
+      <p:pic>
+        <p:nvPicPr>
+          <p:cNvPr id="9" name="">
+            <a:extLst xmlns:a="http://schemas.openxmlformats.org/drawingml/2006/main">
+              <a:ext uri="{FF2B5EF4-FFF2-40B4-BE49-F238E27FC236}">
+                <a16:creationId xmlns:a16="http://schemas.microsoft.com/office/drawing/2014/main" id="{F9A3EBCB-B813-4F32-A99D-16B06971ED7C}"/>
+              </a:ext>
+            </a:extLst>
+          </p:cNvPr>
+          <p:cNvPicPr>
+            <a:picLocks xmlns:a="http://schemas.openxmlformats.org/drawingml/2006/main" noChangeAspect="1"/>
+          </p:cNvPicPr>
+          <p:nvPr/>
+        </p:nvPicPr>
+        <p:blipFill>
+          <a:blip xmlns:r="http://schemas.openxmlformats.org/officeDocument/2006/relationships" xmlns:a="http://schemas.openxmlformats.org/drawingml/2006/main" r:embed="R11d6b3df0ed44198"/>
+          <a:stretch xmlns:a="http://schemas.openxmlformats.org/drawingml/2006/main"/>
+        </p:blipFill>
+        <p:spPr>
+          <a:xfrm xmlns:a="http://schemas.openxmlformats.org/drawingml/2006/main">
+            <a:off x="11096625" y="171450"/>
+            <a:ext cx="381000" cy="381000"/>
+          </a:xfrm>
+          <a:prstGeom xmlns:a="http://schemas.openxmlformats.org/drawingml/2006/main" prst="rect">
+            <a:avLst/>
+          </a:prstGeom>
+        </p:spPr>
+      </p:pic>
       <p:sp>
         <p:nvSpPr>
-          <p:cNvPr id="8" name="closing-nbu">
+          <p:cNvPr id="2" name="closing-nbu">
             <a:extLst xmlns:a="http://schemas.openxmlformats.org/drawingml/2006/main">
               <a:ext uri="{FF2B5EF4-FFF2-40B4-BE49-F238E27FC236}">
-                <a16:creationId xmlns:a16="http://schemas.microsoft.com/office/drawing/2014/main" id="{7C9D9182-4774-4D6A-8AD8-7653F123D07F}"/>
+                <a16:creationId xmlns:a16="http://schemas.microsoft.com/office/drawing/2014/main" id="{DA0E5298-4D3A-4E39-8F46-7103F03B6E77}"/>
               </a:ext>
             </a:extLst>
           </p:cNvPr>
@@ -16502,10 +16587,10 @@
       </p:sp>
       <p:sp>
         <p:nvSpPr>
-          <p:cNvPr id="2" name="closing-slogan">
+          <p:cNvPr id="3" name="closing-slogan">
             <a:extLst xmlns:a="http://schemas.openxmlformats.org/drawingml/2006/main">
               <a:ext uri="{FF2B5EF4-FFF2-40B4-BE49-F238E27FC236}">
-                <a16:creationId xmlns:a16="http://schemas.microsoft.com/office/drawing/2014/main" id="{CB326C21-4DE9-47DA-AC30-C8042A8ECA1A}"/>
+                <a16:creationId xmlns:a16="http://schemas.microsoft.com/office/drawing/2014/main" id="{5FEC8721-84CD-4108-8CE1-E0FF66698CBF}"/>
               </a:ext>
             </a:extLst>
           </p:cNvPr>
@@ -16661,10 +16746,10 @@
       </p:sp>
       <p:sp>
         <p:nvSpPr>
-          <p:cNvPr id="3" name="deliverables-title">
+          <p:cNvPr id="4" name="deliverables-title">
             <a:extLst xmlns:a="http://schemas.openxmlformats.org/drawingml/2006/main">
               <a:ext uri="{FF2B5EF4-FFF2-40B4-BE49-F238E27FC236}">
-                <a16:creationId xmlns:a16="http://schemas.microsoft.com/office/drawing/2014/main" id="{E0C19A33-64D0-4D75-AE04-87D8C955D886}"/>
+                <a16:creationId xmlns:a16="http://schemas.microsoft.com/office/drawing/2014/main" id="{E25592CF-5AC3-4388-897C-D4C729328E18}"/>
               </a:ext>
             </a:extLst>
           </p:cNvPr>
@@ -16820,10 +16905,10 @@
       </p:sp>
       <p:sp>
         <p:nvSpPr>
-          <p:cNvPr id="4" name="deliverables-copy">
+          <p:cNvPr id="5" name="deliverables-copy">
             <a:extLst xmlns:a="http://schemas.openxmlformats.org/drawingml/2006/main">
               <a:ext uri="{FF2B5EF4-FFF2-40B4-BE49-F238E27FC236}">
-                <a16:creationId xmlns:a16="http://schemas.microsoft.com/office/drawing/2014/main" id="{E4E1CCA5-4B31-4717-9111-9BA629D70D57}"/>
+                <a16:creationId xmlns:a16="http://schemas.microsoft.com/office/drawing/2014/main" id="{1C6E723F-C848-482F-A6CF-8C71C488C4BF}"/>
               </a:ext>
             </a:extLst>
           </p:cNvPr>
@@ -16835,7 +16920,7 @@
         <p:spPr>
           <a:xfrm xmlns:a="http://schemas.openxmlformats.org/drawingml/2006/main">
             <a:off x="762000" y="3409950"/>
-            <a:ext cx="9620250" cy="742950"/>
+            <a:ext cx="9810750" cy="742950"/>
           </a:xfrm>
           <a:prstGeom xmlns:a="http://schemas.openxmlformats.org/drawingml/2006/main" prst="rect">
             <a:avLst/>
@@ -16976,7 +17061,7 @@
                 <a:ea typeface="Arial"/>
                 <a:cs typeface="Arial"/>
               </a:rPr>
-              <a:t>Código web y de escritorio · Script SQL Server</a:t>
+              <a:t>Código web y escritorio · Script SQL Server · Ficha técnica</a:t>
             </a:r>
           </a:p>
           <a:p xmlns:a="http://schemas.openxmlformats.org/drawingml/2006/main">
@@ -17003,17 +17088,17 @@
                 <a:ea typeface="Arial"/>
                 <a:cs typeface="Arial"/>
               </a:rPr>
-              <a:t>Documentación técnica y manual · Ejecutable Windows</a:t>
+              <a:t>Manual de usuario · Documentación · Presentación · Ejecutable Windows</a:t>
             </a:r>
           </a:p>
         </p:txBody>
       </p:sp>
       <p:sp>
         <p:nvSpPr>
-          <p:cNvPr id="5" name="team-line">
+          <p:cNvPr id="6" name="team-line">
             <a:extLst xmlns:a="http://schemas.openxmlformats.org/drawingml/2006/main">
               <a:ext uri="{FF2B5EF4-FFF2-40B4-BE49-F238E27FC236}">
-                <a16:creationId xmlns:a16="http://schemas.microsoft.com/office/drawing/2014/main" id="{37080075-7182-4EE4-864E-587CEDBEAC5B}"/>
+                <a16:creationId xmlns:a16="http://schemas.microsoft.com/office/drawing/2014/main" id="{04D9B959-840D-4D0C-89F6-EC408553B71B}"/>
               </a:ext>
             </a:extLst>
           </p:cNvPr>
@@ -17169,10 +17254,10 @@
       </p:sp>
       <p:sp>
         <p:nvSpPr>
-          <p:cNvPr id="6" name="team-names">
+          <p:cNvPr id="7" name="team-names">
             <a:extLst xmlns:a="http://schemas.openxmlformats.org/drawingml/2006/main">
               <a:ext uri="{FF2B5EF4-FFF2-40B4-BE49-F238E27FC236}">
-                <a16:creationId xmlns:a16="http://schemas.microsoft.com/office/drawing/2014/main" id="{D1F00C5D-B1DF-489E-AD4A-9037DE6B8C63}"/>
+                <a16:creationId xmlns:a16="http://schemas.microsoft.com/office/drawing/2014/main" id="{9426ED04-550E-4755-BF7E-7538C040D7AC}"/>
               </a:ext>
             </a:extLst>
           </p:cNvPr>
@@ -17183,8 +17268,8 @@
         </p:nvSpPr>
         <p:spPr>
           <a:xfrm xmlns:a="http://schemas.openxmlformats.org/drawingml/2006/main">
-            <a:off x="762000" y="4962525"/>
-            <a:ext cx="5619750" cy="1047750"/>
+            <a:off x="762000" y="4905375"/>
+            <a:ext cx="5905500" cy="1200150"/>
           </a:xfrm>
           <a:prstGeom xmlns:a="http://schemas.openxmlformats.org/drawingml/2006/main" prst="rect">
             <a:avLst/>
@@ -17201,7 +17286,7 @@
           </a:bodyPr>
           <a:lstStyle xmlns:a="http://schemas.openxmlformats.org/drawingml/2006/main">
             <a:defPPr algn="l">
-              <a:defRPr sz="1500">
+              <a:defRPr sz="1425">
                 <a:solidFill>
                   <a:srgbClr val="FFFFFF"/>
                 </a:solidFill>
@@ -17211,7 +17296,7 @@
               </a:defRPr>
             </a:defPPr>
             <a:lvl1pPr algn="l">
-              <a:defRPr sz="1500">
+              <a:defRPr sz="1425">
                 <a:solidFill>
                   <a:srgbClr val="FFFFFF"/>
                 </a:solidFill>
@@ -17221,7 +17306,7 @@
               </a:defRPr>
             </a:lvl1pPr>
             <a:lvl2pPr algn="l">
-              <a:defRPr sz="1500">
+              <a:defRPr sz="1425">
                 <a:solidFill>
                   <a:srgbClr val="FFFFFF"/>
                 </a:solidFill>
@@ -17231,7 +17316,7 @@
               </a:defRPr>
             </a:lvl2pPr>
             <a:lvl3pPr algn="l">
-              <a:defRPr sz="1500">
+              <a:defRPr sz="1425">
                 <a:solidFill>
                   <a:srgbClr val="FFFFFF"/>
                 </a:solidFill>
@@ -17241,7 +17326,7 @@
               </a:defRPr>
             </a:lvl3pPr>
             <a:lvl4pPr algn="l">
-              <a:defRPr sz="1500">
+              <a:defRPr sz="1425">
                 <a:solidFill>
                   <a:srgbClr val="FFFFFF"/>
                 </a:solidFill>
@@ -17251,7 +17336,7 @@
               </a:defRPr>
             </a:lvl4pPr>
             <a:lvl5pPr algn="l">
-              <a:defRPr sz="1500">
+              <a:defRPr sz="1425">
                 <a:solidFill>
                   <a:srgbClr val="FFFFFF"/>
                 </a:solidFill>
@@ -17261,7 +17346,7 @@
               </a:defRPr>
             </a:lvl5pPr>
             <a:lvl6pPr algn="l">
-              <a:defRPr sz="1500">
+              <a:defRPr sz="1425">
                 <a:solidFill>
                   <a:srgbClr val="FFFFFF"/>
                 </a:solidFill>
@@ -17271,7 +17356,7 @@
               </a:defRPr>
             </a:lvl6pPr>
             <a:lvl7pPr algn="l">
-              <a:defRPr sz="1500">
+              <a:defRPr sz="1425">
                 <a:solidFill>
                   <a:srgbClr val="FFFFFF"/>
                 </a:solidFill>
@@ -17281,7 +17366,7 @@
               </a:defRPr>
             </a:lvl7pPr>
             <a:lvl8pPr algn="l">
-              <a:defRPr sz="1500">
+              <a:defRPr sz="1425">
                 <a:solidFill>
                   <a:srgbClr val="FFFFFF"/>
                 </a:solidFill>
@@ -17291,7 +17376,7 @@
               </a:defRPr>
             </a:lvl8pPr>
             <a:lvl9pPr algn="l">
-              <a:defRPr sz="1500">
+              <a:defRPr sz="1425">
                 <a:solidFill>
                   <a:srgbClr val="FFFFFF"/>
                 </a:solidFill>
@@ -17304,10 +17389,10 @@
           <a:p xmlns:a="http://schemas.openxmlformats.org/drawingml/2006/main">
             <a:pPr algn="l">
               <a:lnSpc>
-                <a:spcPct val="108000"/>
+                <a:spcPct val="104000"/>
               </a:lnSpc>
               <a:buNone/>
-              <a:defRPr sz="1500">
+              <a:defRPr sz="1425">
                 <a:solidFill>
                   <a:srgbClr val="FFFFFF"/>
                 </a:solidFill>
@@ -17317,7 +17402,7 @@
               </a:defRPr>
             </a:pPr>
             <a:r>
-              <a:rPr sz="1500">
+              <a:rPr sz="1425">
                 <a:solidFill>
                   <a:srgbClr val="FFFFFF"/>
                 </a:solidFill>
@@ -17331,10 +17416,10 @@
           <a:p xmlns:a="http://schemas.openxmlformats.org/drawingml/2006/main">
             <a:pPr algn="l">
               <a:lnSpc>
-                <a:spcPct val="108000"/>
+                <a:spcPct val="104000"/>
               </a:lnSpc>
               <a:buNone/>
-              <a:defRPr sz="1500">
+              <a:defRPr sz="1425">
                 <a:solidFill>
                   <a:srgbClr val="FFFFFF"/>
                 </a:solidFill>
@@ -17344,7 +17429,7 @@
               </a:defRPr>
             </a:pPr>
             <a:r>
-              <a:rPr sz="1500">
+              <a:rPr sz="1425">
                 <a:solidFill>
                   <a:srgbClr val="FFFFFF"/>
                 </a:solidFill>
@@ -17358,10 +17443,10 @@
           <a:p xmlns:a="http://schemas.openxmlformats.org/drawingml/2006/main">
             <a:pPr algn="l">
               <a:lnSpc>
-                <a:spcPct val="108000"/>
+                <a:spcPct val="104000"/>
               </a:lnSpc>
               <a:buNone/>
-              <a:defRPr sz="1500">
+              <a:defRPr sz="1425">
                 <a:solidFill>
                   <a:srgbClr val="FFFFFF"/>
                 </a:solidFill>
@@ -17371,7 +17456,7 @@
               </a:defRPr>
             </a:pPr>
             <a:r>
-              <a:rPr sz="1500">
+              <a:rPr sz="1425">
                 <a:solidFill>
                   <a:srgbClr val="FFFFFF"/>
                 </a:solidFill>
@@ -17380,16 +17465,43 @@
                 <a:cs typeface="Arial"/>
               </a:rPr>
               <a:t>Dereck Sahid Davila Duarte</a:t>
+            </a:r>
+          </a:p>
+          <a:p xmlns:a="http://schemas.openxmlformats.org/drawingml/2006/main">
+            <a:pPr algn="l">
+              <a:lnSpc>
+                <a:spcPct val="104000"/>
+              </a:lnSpc>
+              <a:buNone/>
+              <a:defRPr sz="1425">
+                <a:solidFill>
+                  <a:srgbClr val="FFFFFF"/>
+                </a:solidFill>
+                <a:latin typeface="Arial"/>
+                <a:ea typeface="Arial"/>
+                <a:cs typeface="Arial"/>
+              </a:defRPr>
+            </a:pPr>
+            <a:r>
+              <a:rPr sz="1425">
+                <a:solidFill>
+                  <a:srgbClr val="FFFFFF"/>
+                </a:solidFill>
+                <a:latin typeface="Arial"/>
+                <a:ea typeface="Arial"/>
+                <a:cs typeface="Arial"/>
+              </a:rPr>
+              <a:t>Ismael Exequiel Noguera Arias</a:t>
             </a:r>
           </a:p>
         </p:txBody>
       </p:sp>
       <p:sp>
         <p:nvSpPr>
-          <p:cNvPr id="7" name="repo">
+          <p:cNvPr id="8" name="repo">
             <a:extLst xmlns:a="http://schemas.openxmlformats.org/drawingml/2006/main">
               <a:ext uri="{FF2B5EF4-FFF2-40B4-BE49-F238E27FC236}">
-                <a16:creationId xmlns:a16="http://schemas.microsoft.com/office/drawing/2014/main" id="{F8984C6B-F3F5-4CFF-AC25-ADACB9045D20}"/>
+                <a16:creationId xmlns:a16="http://schemas.microsoft.com/office/drawing/2014/main" id="{00C08F69-0F16-4702-95B3-C16021D7AD40}"/>
               </a:ext>
             </a:extLst>
           </p:cNvPr>
@@ -17546,7 +17658,7 @@
     </p:spTree>
     <p:extLst>
       <p:ext uri="{BB962C8B-B14F-4D97-AF65-F5344CB8AC3E}">
-        <p14:creationId xmlns:p14="http://schemas.microsoft.com/office/powerpoint/2010/main" val="1822996552"/>
+        <p14:creationId xmlns:p14="http://schemas.microsoft.com/office/powerpoint/2010/main" val="1904950448"/>
       </p:ext>
     </p:extLst>
   </p:cSld>

</xml_diff>